<commit_message>
feat: integrate verified PolicyFuzz application and team handoffs
Complete the policy, fuzzing, deterministic evaluation and FastAPI workstreams against frozen version 1.0 contracts. Add recorded scripted demo evidence, repeatable cached sessions, release verification tools, CI and updated submission drafts.

Verified: 1,438 backend tests, 108 frontend tests, production build, 111 schemas, three deterministic replays and public development/control benchmark checks.

Independent reviews approved. Live provider/browser acceptance, human blind evaluation, first-run discovery reconciliation, the six-hour release freeze and final media remain explicitly pending. No final release tag or fabricated approval is included.

Reviewed local implementation: 0a1e5a37e148775003a84c0028d5285d60361263
Verified tree: 50370d1fdb333ff846ce6d81bdf27aed441525c5
</commit_message>
<xml_diff>
--- a/submission/deck/PolicyFuzz-Pitch-Draft.pptx
+++ b/submission/deck/PolicyFuzz-Pitch-Draft.pptx
@@ -2,21 +2,21 @@
 <file path=ppt/presentation.xml><?xml version="1.0" encoding="utf-8"?>
 <p:presentation xmlns:p="http://schemas.openxmlformats.org/presentationml/2006/main">
   <p:sldMasterIdLst>
-    <p:sldMasterId xmlns:r="http://schemas.openxmlformats.org/officeDocument/2006/relationships" id="2147483648" r:id="Ra0a1175fb6d544b8"/>
+    <p:sldMasterId xmlns:r="http://schemas.openxmlformats.org/officeDocument/2006/relationships" id="2147483648" r:id="R68a50fb1041a4517"/>
   </p:sldMasterIdLst>
   <p:notesMasterIdLst>
-    <p:notesMasterId xmlns:r="http://schemas.openxmlformats.org/officeDocument/2006/relationships" r:id="R8c281c3e069642fa"/>
+    <p:notesMasterId xmlns:r="http://schemas.openxmlformats.org/officeDocument/2006/relationships" r:id="R090b698c25f243ec"/>
   </p:notesMasterIdLst>
   <p:sldIdLst>
-    <p:sldId xmlns:r="http://schemas.openxmlformats.org/officeDocument/2006/relationships" id="256" r:id="R91e4ac0f30c64aeb"/>
-    <p:sldId xmlns:r="http://schemas.openxmlformats.org/officeDocument/2006/relationships" id="257" r:id="R28aaf402cd4b41ef"/>
-    <p:sldId xmlns:r="http://schemas.openxmlformats.org/officeDocument/2006/relationships" id="258" r:id="Rc4b768cdb0ff4183"/>
-    <p:sldId xmlns:r="http://schemas.openxmlformats.org/officeDocument/2006/relationships" id="259" r:id="R780ac531285541af"/>
-    <p:sldId xmlns:r="http://schemas.openxmlformats.org/officeDocument/2006/relationships" id="260" r:id="Rdca767b362784f36"/>
-    <p:sldId xmlns:r="http://schemas.openxmlformats.org/officeDocument/2006/relationships" id="261" r:id="R740c359cfdc24201"/>
-    <p:sldId xmlns:r="http://schemas.openxmlformats.org/officeDocument/2006/relationships" id="262" r:id="R6de24ba56b834d8d"/>
-    <p:sldId xmlns:r="http://schemas.openxmlformats.org/officeDocument/2006/relationships" id="263" r:id="R62cd59835c384293"/>
-    <p:sldId xmlns:r="http://schemas.openxmlformats.org/officeDocument/2006/relationships" id="264" r:id="R61d6dcafa3524cbb"/>
+    <p:sldId xmlns:r="http://schemas.openxmlformats.org/officeDocument/2006/relationships" id="256" r:id="R4de847c2c8e54078"/>
+    <p:sldId xmlns:r="http://schemas.openxmlformats.org/officeDocument/2006/relationships" id="257" r:id="R7fe8070bc00f4cd9"/>
+    <p:sldId xmlns:r="http://schemas.openxmlformats.org/officeDocument/2006/relationships" id="258" r:id="Re2df77f0498d4e3a"/>
+    <p:sldId xmlns:r="http://schemas.openxmlformats.org/officeDocument/2006/relationships" id="259" r:id="R3442d6bd086a4228"/>
+    <p:sldId xmlns:r="http://schemas.openxmlformats.org/officeDocument/2006/relationships" id="260" r:id="Re21bcf75a66d4358"/>
+    <p:sldId xmlns:r="http://schemas.openxmlformats.org/officeDocument/2006/relationships" id="261" r:id="Rd42042568ba84472"/>
+    <p:sldId xmlns:r="http://schemas.openxmlformats.org/officeDocument/2006/relationships" id="262" r:id="R62247b7e0ab84c5d"/>
+    <p:sldId xmlns:r="http://schemas.openxmlformats.org/officeDocument/2006/relationships" id="263" r:id="Rcd86860ee8a0454a"/>
+    <p:sldId xmlns:r="http://schemas.openxmlformats.org/officeDocument/2006/relationships" id="264" r:id="R80a76c16c5ad47de"/>
   </p:sldIdLst>
   <p:sldSz cx="12192000" cy="6858000"/>
   <p:notesSz cx="6858000" cy="9144000"/>
@@ -750,12 +750,12 @@
           <a:lstStyle xmlns:a="http://schemas.openxmlformats.org/drawingml/2006/main"/>
           <a:p xmlns:a="http://schemas.openxmlformats.org/drawingml/2006/main">
             <a:r>
-              <a:t>Explain that the agentic behavior is bounded by a single targeted cycle.</a:t>
-            </a:r>
-          </a:p>
-          <a:p xmlns:a="http://schemas.openxmlformats.org/drawingml/2006/main">
-            <a:r>
-              <a:t>If coverage remains insufficient, the workflow stops rather than expanding without limit.</a:t>
+              <a:t>The current cached rehearsal satisfies minimum coverage in the initial provisional suite, so it freezes without adaptation.</a:t>
+            </a:r>
+          </a:p>
+          <a:p xmlns:a="http://schemas.openxmlformats.org/drawingml/2006/main">
+            <a:r>
+              <a:t>One targeted cycle remains the upper bound when coverage is missing; it is not a mandatory step.</a:t>
             </a:r>
           </a:p>
           <a:p xmlns:a="http://schemas.openxmlformats.org/drawingml/2006/main">
@@ -770,7 +770,7 @@
           </a:p>
           <a:p xmlns:a="http://schemas.openxmlformats.org/drawingml/2006/main">
             <a:r>
-              <a:t>- docs/superpowers/plans/2026-09-04-policyfuzz-implementation.md — Tasks 9 and 24</a:t>
+              <a:t>- samples/cached-demo/run-record.json — scenario suite statistics and coverage</a:t>
             </a:r>
           </a:p>
           <a:p xmlns:a="http://schemas.openxmlformats.org/drawingml/2006/main">
@@ -955,12 +955,12 @@
           <a:lstStyle xmlns:a="http://schemas.openxmlformats.org/drawingml/2006/main"/>
           <a:p xmlns:a="http://schemas.openxmlformats.org/drawingml/2006/main">
             <a:r>
-              <a:t>Describe these as synthetic planned development cases, not observed findings.</a:t>
-            </a:r>
-          </a:p>
-          <a:p xmlns:a="http://schemas.openxmlformats.org/drawingml/2006/main">
-            <a:r>
-              <a:t>The amount facts instantiate the approved defect definitions; final witnesses, traces, and policy-span citations remain capture dependencies.</a:t>
+              <a:t>Describe these as findings in the current public cached rehearsal, not frozen benchmark claims.</a:t>
+            </a:r>
+          </a:p>
+          <a:p xmlns:a="http://schemas.openxmlformats.org/drawingml/2006/main">
+            <a:r>
+              <a:t>Exact browser witnesses, traces, and policy-span citations remain capture dependencies.</a:t>
             </a:r>
           </a:p>
           <a:p xmlns:a="http://schemas.openxmlformats.org/drawingml/2006/main">
@@ -975,12 +975,12 @@
           </a:p>
           <a:p xmlns:a="http://schemas.openxmlformats.org/drawingml/2006/main">
             <a:r>
-              <a:t>- docs/superpowers/specs/2026-09-04-policyfuzz-design.md — §12.1 development demonstration cases</a:t>
-            </a:r>
-          </a:p>
-          <a:p xmlns:a="http://schemas.openxmlformats.org/drawingml/2006/main">
-            <a:r>
-              <a:t>- docs/superpowers/plans/2026-09-04-policyfuzz-implementation.md — Task 21 fixture contract and Task 24, slide 6</a:t>
+              <a:t>- samples/cached-demo/run-record.json — baseline finding report and authored decisions</a:t>
+            </a:r>
+          </a:p>
+          <a:p xmlns:a="http://schemas.openxmlformats.org/drawingml/2006/main">
+            <a:r>
+              <a:t>- samples/cached-demo/summary.json — baseline finding count and cached provenance</a:t>
             </a:r>
           </a:p>
           <a:p xmlns:a="http://schemas.openxmlformats.org/drawingml/2006/main">
@@ -1055,12 +1055,12 @@
           <a:lstStyle xmlns:a="http://schemas.openxmlformats.org/drawingml/2006/main"/>
           <a:p xmlns:a="http://schemas.openxmlformats.org/drawingml/2006/main">
             <a:r>
-              <a:t>Do not present placeholder values as measurements.</a:t>
-            </a:r>
-          </a:p>
-          <a:p xmlns:a="http://schemas.openxmlformats.org/drawingml/2006/main">
-            <a:r>
-              <a:t>Explain the evidence chain and disclose the blind candidate's late seal, delegated-agent authorship, pending human review, and scoring ineligibility.</a:t>
+              <a:t>These are measured values from the current public cached rehearsal record, not final verified metrics.</a:t>
+            </a:r>
+          </a:p>
+          <a:p xmlns:a="http://schemas.openxmlformats.org/drawingml/2006/main">
+            <a:r>
+              <a:t>Keep synthetic, cached, scripted, and blind-ineligible labels visible; final claims still require Gate B, freeze, capture, and human review.</a:t>
             </a:r>
           </a:p>
           <a:p xmlns:a="http://schemas.openxmlformats.org/drawingml/2006/main">
@@ -1075,17 +1075,12 @@
           </a:p>
           <a:p xmlns:a="http://schemas.openxmlformats.org/drawingml/2006/main">
             <a:r>
-              <a:t>- docs/superpowers/plans/2026-09-04-policyfuzz-implementation.md — Gate B and Task 24, steps 1–2</a:t>
-            </a:r>
-          </a:p>
-          <a:p xmlns:a="http://schemas.openxmlformats.org/drawingml/2006/main">
-            <a:r>
-              <a:t>- docs/superpowers/specs/2026-09-04-policyfuzz-design.md — §§12.2–12.4 and 18</a:t>
-            </a:r>
-          </a:p>
-          <a:p xmlns:a="http://schemas.openxmlformats.org/drawingml/2006/main">
-            <a:r>
-              <a:t>- submission/evidence/benchmark-v2/README.md</a:t>
+              <a:t>- samples/cached-demo/summary.json</a:t>
+            </a:r>
+          </a:p>
+          <a:p xmlns:a="http://schemas.openxmlformats.org/drawingml/2006/main">
+            <a:r>
+              <a:t>- samples/cached-demo/run-record.json</a:t>
             </a:r>
           </a:p>
           <a:p xmlns:a="http://schemas.openxmlformats.org/drawingml/2006/main">
@@ -1373,7 +1368,7 @@
   </p:cSld>
   <p:clrMap bg1="lt1" tx1="dk1" bg2="lt2" tx2="dk2" accent1="accent1" accent2="accent2" accent3="accent3" accent4="accent4" accent5="accent5" accent6="accent6" hlink="hlink" folHlink="folHlink"/>
   <p:sldLayoutIdLst>
-    <p:sldLayoutId xmlns:r="http://schemas.openxmlformats.org/officeDocument/2006/relationships" id="2147483649" r:id="Rba581d740bb04b43"/>
+    <p:sldLayoutId xmlns:r="http://schemas.openxmlformats.org/officeDocument/2006/relationships" id="2147483649" r:id="R6e7b9c9e910e4061"/>
   </p:sldLayoutIdLst>
   <p:txStyles>
     <p:titleStyle>
@@ -1924,7 +1919,7 @@
           <p:cNvPr id="9" name="">
             <a:extLst xmlns:a="http://schemas.openxmlformats.org/drawingml/2006/main">
               <a:ext uri="{FF2B5EF4-FFF2-40B4-BE49-F238E27FC236}">
-                <a16:creationId xmlns:a16="http://schemas.microsoft.com/office/drawing/2014/main" id="{DE6B0869-5F03-4A4C-AF90-FC3EEEF2A80F}"/>
+                <a16:creationId xmlns:a16="http://schemas.microsoft.com/office/drawing/2014/main" id="{C0760335-883D-487C-9350-6A57B3E30157}"/>
               </a:ext>
             </a:extLst>
           </p:cNvPr>
@@ -1955,7 +1950,7 @@
           <p:cNvPr id="2" name="">
             <a:extLst xmlns:a="http://schemas.openxmlformats.org/drawingml/2006/main">
               <a:ext uri="{FF2B5EF4-FFF2-40B4-BE49-F238E27FC236}">
-                <a16:creationId xmlns:a16="http://schemas.microsoft.com/office/drawing/2014/main" id="{EC679253-5BAD-4445-ABCB-AAF14E0D265E}"/>
+                <a16:creationId xmlns:a16="http://schemas.microsoft.com/office/drawing/2014/main" id="{94BF83B8-3C21-4938-B841-C95EAB543030}"/>
               </a:ext>
             </a:extLst>
           </p:cNvPr>
@@ -1986,7 +1981,7 @@
           <p:cNvPr id="3" name="">
             <a:extLst xmlns:a="http://schemas.openxmlformats.org/drawingml/2006/main">
               <a:ext uri="{FF2B5EF4-FFF2-40B4-BE49-F238E27FC236}">
-                <a16:creationId xmlns:a16="http://schemas.microsoft.com/office/drawing/2014/main" id="{E110D5C8-620A-4E74-BE1D-F3D40C2180D8}"/>
+                <a16:creationId xmlns:a16="http://schemas.microsoft.com/office/drawing/2014/main" id="{983FF10F-9235-487A-ACC6-42A921EAF6AA}"/>
               </a:ext>
             </a:extLst>
           </p:cNvPr>
@@ -2036,7 +2031,7 @@
           <p:cNvPr id="4" name="">
             <a:extLst xmlns:a="http://schemas.openxmlformats.org/drawingml/2006/main">
               <a:ext uri="{FF2B5EF4-FFF2-40B4-BE49-F238E27FC236}">
-                <a16:creationId xmlns:a16="http://schemas.microsoft.com/office/drawing/2014/main" id="{C3C1C58D-C78B-4D20-A1A6-B2C06B3C3034}"/>
+                <a16:creationId xmlns:a16="http://schemas.microsoft.com/office/drawing/2014/main" id="{266D18DA-DB29-4497-91D0-645C7612AB85}"/>
               </a:ext>
             </a:extLst>
           </p:cNvPr>
@@ -2103,7 +2098,7 @@
           <p:cNvPr id="5" name="">
             <a:extLst xmlns:a="http://schemas.openxmlformats.org/drawingml/2006/main">
               <a:ext uri="{FF2B5EF4-FFF2-40B4-BE49-F238E27FC236}">
-                <a16:creationId xmlns:a16="http://schemas.microsoft.com/office/drawing/2014/main" id="{B5335A6B-313B-480C-9BAF-68D64616C118}"/>
+                <a16:creationId xmlns:a16="http://schemas.microsoft.com/office/drawing/2014/main" id="{B93E05DB-DFC7-48CD-AA69-BD0149560F9D}"/>
               </a:ext>
             </a:extLst>
           </p:cNvPr>
@@ -2153,7 +2148,7 @@
           <p:cNvPr id="6" name="">
             <a:extLst xmlns:a="http://schemas.openxmlformats.org/drawingml/2006/main">
               <a:ext uri="{FF2B5EF4-FFF2-40B4-BE49-F238E27FC236}">
-                <a16:creationId xmlns:a16="http://schemas.microsoft.com/office/drawing/2014/main" id="{921D98B0-D068-458F-83DB-5861350B1B38}"/>
+                <a16:creationId xmlns:a16="http://schemas.microsoft.com/office/drawing/2014/main" id="{4C6C69BB-B029-4D80-A540-B94A79F6982D}"/>
               </a:ext>
             </a:extLst>
           </p:cNvPr>
@@ -2207,7 +2202,7 @@
           <p:cNvPr id="7" name="">
             <a:extLst xmlns:a="http://schemas.openxmlformats.org/drawingml/2006/main">
               <a:ext uri="{FF2B5EF4-FFF2-40B4-BE49-F238E27FC236}">
-                <a16:creationId xmlns:a16="http://schemas.microsoft.com/office/drawing/2014/main" id="{E0D95EAA-283B-431D-A29D-5B4CC47F7E99}"/>
+                <a16:creationId xmlns:a16="http://schemas.microsoft.com/office/drawing/2014/main" id="{82F4D032-5505-4E33-815D-F80840495CA5}"/>
               </a:ext>
             </a:extLst>
           </p:cNvPr>
@@ -2257,7 +2252,7 @@
           <p:cNvPr id="8" name="">
             <a:extLst xmlns:a="http://schemas.openxmlformats.org/drawingml/2006/main">
               <a:ext uri="{FF2B5EF4-FFF2-40B4-BE49-F238E27FC236}">
-                <a16:creationId xmlns:a16="http://schemas.microsoft.com/office/drawing/2014/main" id="{AE8C7CBE-D0D5-4CCF-905E-F3B7D7823A82}"/>
+                <a16:creationId xmlns:a16="http://schemas.microsoft.com/office/drawing/2014/main" id="{0E90278E-D8CF-4A4B-BA11-F5C6CD37BE48}"/>
               </a:ext>
             </a:extLst>
           </p:cNvPr>
@@ -2322,7 +2317,7 @@
     </p:spTree>
     <p:extLst>
       <p:ext uri="{BB962C8B-B14F-4D97-AF65-F5344CB8AC3E}">
-        <p14:creationId xmlns:p14="http://schemas.microsoft.com/office/powerpoint/2010/main" val="1382384054"/>
+        <p14:creationId xmlns:p14="http://schemas.microsoft.com/office/powerpoint/2010/main" val="1953858730"/>
       </p:ext>
     </p:extLst>
   </p:cSld>
@@ -2353,7 +2348,7 @@
           <p:cNvPr id="21" name="">
             <a:extLst xmlns:a="http://schemas.openxmlformats.org/drawingml/2006/main">
               <a:ext uri="{FF2B5EF4-FFF2-40B4-BE49-F238E27FC236}">
-                <a16:creationId xmlns:a16="http://schemas.microsoft.com/office/drawing/2014/main" id="{2F3E1253-C919-42B4-B2B8-F10D63E4DC65}"/>
+                <a16:creationId xmlns:a16="http://schemas.microsoft.com/office/drawing/2014/main" id="{51E84126-91B2-40AE-8586-3AE9D70E5BA8}"/>
               </a:ext>
             </a:extLst>
           </p:cNvPr>
@@ -2384,7 +2379,7 @@
           <p:cNvPr id="2" name="">
             <a:extLst xmlns:a="http://schemas.openxmlformats.org/drawingml/2006/main">
               <a:ext uri="{FF2B5EF4-FFF2-40B4-BE49-F238E27FC236}">
-                <a16:creationId xmlns:a16="http://schemas.microsoft.com/office/drawing/2014/main" id="{D5D5A770-6EF7-415A-9C12-6F1BDC6F7D65}"/>
+                <a16:creationId xmlns:a16="http://schemas.microsoft.com/office/drawing/2014/main" id="{6BEC7DA0-B63C-42B7-AE1A-9A405B0E93EC}"/>
               </a:ext>
             </a:extLst>
           </p:cNvPr>
@@ -2434,7 +2429,7 @@
           <p:cNvPr id="3" name="">
             <a:extLst xmlns:a="http://schemas.openxmlformats.org/drawingml/2006/main">
               <a:ext uri="{FF2B5EF4-FFF2-40B4-BE49-F238E27FC236}">
-                <a16:creationId xmlns:a16="http://schemas.microsoft.com/office/drawing/2014/main" id="{0EC6FD85-4161-4D05-8DAD-FCFC195F942E}"/>
+                <a16:creationId xmlns:a16="http://schemas.microsoft.com/office/drawing/2014/main" id="{8C9C08F2-836A-457E-9742-7ABEE2887D56}"/>
               </a:ext>
             </a:extLst>
           </p:cNvPr>
@@ -2484,7 +2479,7 @@
           <p:cNvPr id="4" name="">
             <a:extLst xmlns:a="http://schemas.openxmlformats.org/drawingml/2006/main">
               <a:ext uri="{FF2B5EF4-FFF2-40B4-BE49-F238E27FC236}">
-                <a16:creationId xmlns:a16="http://schemas.microsoft.com/office/drawing/2014/main" id="{06736764-4106-4881-8FD3-ACE7993DAF62}"/>
+                <a16:creationId xmlns:a16="http://schemas.microsoft.com/office/drawing/2014/main" id="{70966F64-8ED5-445D-A43C-A67A42C448DD}"/>
               </a:ext>
             </a:extLst>
           </p:cNvPr>
@@ -2515,7 +2510,7 @@
           <p:cNvPr id="5" name="">
             <a:extLst xmlns:a="http://schemas.openxmlformats.org/drawingml/2006/main">
               <a:ext uri="{FF2B5EF4-FFF2-40B4-BE49-F238E27FC236}">
-                <a16:creationId xmlns:a16="http://schemas.microsoft.com/office/drawing/2014/main" id="{353C118C-D7BA-45CB-8B28-6D8F8B8F4267}"/>
+                <a16:creationId xmlns:a16="http://schemas.microsoft.com/office/drawing/2014/main" id="{AE78F31F-0F8B-4AD5-AAF7-984E0E4B066F}"/>
               </a:ext>
             </a:extLst>
           </p:cNvPr>
@@ -2565,7 +2560,7 @@
           <p:cNvPr id="6" name="">
             <a:extLst xmlns:a="http://schemas.openxmlformats.org/drawingml/2006/main">
               <a:ext uri="{FF2B5EF4-FFF2-40B4-BE49-F238E27FC236}">
-                <a16:creationId xmlns:a16="http://schemas.microsoft.com/office/drawing/2014/main" id="{32E187BC-41CD-42CA-AE7B-AAEF76A97973}"/>
+                <a16:creationId xmlns:a16="http://schemas.microsoft.com/office/drawing/2014/main" id="{E3982C7B-395B-4D36-84B7-88ECFD7CDD0B}"/>
               </a:ext>
             </a:extLst>
           </p:cNvPr>
@@ -2615,7 +2610,7 @@
           <p:cNvPr id="7" name="">
             <a:extLst xmlns:a="http://schemas.openxmlformats.org/drawingml/2006/main">
               <a:ext uri="{FF2B5EF4-FFF2-40B4-BE49-F238E27FC236}">
-                <a16:creationId xmlns:a16="http://schemas.microsoft.com/office/drawing/2014/main" id="{78527DB5-08E8-4C91-92F6-AAC9DD6B4366}"/>
+                <a16:creationId xmlns:a16="http://schemas.microsoft.com/office/drawing/2014/main" id="{04FF34CF-49FB-4F32-87F3-9D7853376150}"/>
               </a:ext>
             </a:extLst>
           </p:cNvPr>
@@ -2665,7 +2660,7 @@
           <p:cNvPr id="8" name="">
             <a:extLst xmlns:a="http://schemas.openxmlformats.org/drawingml/2006/main">
               <a:ext uri="{FF2B5EF4-FFF2-40B4-BE49-F238E27FC236}">
-                <a16:creationId xmlns:a16="http://schemas.microsoft.com/office/drawing/2014/main" id="{98E51D87-7F34-4AC3-B3DE-A206D9A1A8EC}"/>
+                <a16:creationId xmlns:a16="http://schemas.microsoft.com/office/drawing/2014/main" id="{46C80B49-2DD8-48EF-9288-2EA74DCF2B79}"/>
               </a:ext>
             </a:extLst>
           </p:cNvPr>
@@ -2715,7 +2710,7 @@
           <p:cNvPr id="9" name="">
             <a:extLst xmlns:a="http://schemas.openxmlformats.org/drawingml/2006/main">
               <a:ext uri="{FF2B5EF4-FFF2-40B4-BE49-F238E27FC236}">
-                <a16:creationId xmlns:a16="http://schemas.microsoft.com/office/drawing/2014/main" id="{06EC0855-26C5-4EE8-9409-746760D473D2}"/>
+                <a16:creationId xmlns:a16="http://schemas.microsoft.com/office/drawing/2014/main" id="{5795DAA6-90EE-4043-9D4A-50FAC49D211D}"/>
               </a:ext>
             </a:extLst>
           </p:cNvPr>
@@ -2765,7 +2760,7 @@
           <p:cNvPr id="10" name="">
             <a:extLst xmlns:a="http://schemas.openxmlformats.org/drawingml/2006/main">
               <a:ext uri="{FF2B5EF4-FFF2-40B4-BE49-F238E27FC236}">
-                <a16:creationId xmlns:a16="http://schemas.microsoft.com/office/drawing/2014/main" id="{1F28DCB6-E000-4E91-97FB-8977DD3483BF}"/>
+                <a16:creationId xmlns:a16="http://schemas.microsoft.com/office/drawing/2014/main" id="{7AC176F8-3EBA-4450-8409-5412BAA69EE4}"/>
               </a:ext>
             </a:extLst>
           </p:cNvPr>
@@ -2819,7 +2814,7 @@
           <p:cNvPr id="11" name="">
             <a:extLst xmlns:a="http://schemas.openxmlformats.org/drawingml/2006/main">
               <a:ext uri="{FF2B5EF4-FFF2-40B4-BE49-F238E27FC236}">
-                <a16:creationId xmlns:a16="http://schemas.microsoft.com/office/drawing/2014/main" id="{19AEC533-B5C4-4BE7-A1D6-8EBBFA92FC69}"/>
+                <a16:creationId xmlns:a16="http://schemas.microsoft.com/office/drawing/2014/main" id="{78DE4A21-11F5-4B09-86E4-CE8188A0F8AC}"/>
               </a:ext>
             </a:extLst>
           </p:cNvPr>
@@ -2850,7 +2845,7 @@
           <p:cNvPr id="12" name="">
             <a:extLst xmlns:a="http://schemas.openxmlformats.org/drawingml/2006/main">
               <a:ext uri="{FF2B5EF4-FFF2-40B4-BE49-F238E27FC236}">
-                <a16:creationId xmlns:a16="http://schemas.microsoft.com/office/drawing/2014/main" id="{CEBFB479-A620-47F3-AED3-AB3FF0D0FE07}"/>
+                <a16:creationId xmlns:a16="http://schemas.microsoft.com/office/drawing/2014/main" id="{DBEB6B7E-38C4-4B04-BD92-60F9F15A6E28}"/>
               </a:ext>
             </a:extLst>
           </p:cNvPr>
@@ -2904,7 +2899,7 @@
           <p:cNvPr id="13" name="">
             <a:extLst xmlns:a="http://schemas.openxmlformats.org/drawingml/2006/main">
               <a:ext uri="{FF2B5EF4-FFF2-40B4-BE49-F238E27FC236}">
-                <a16:creationId xmlns:a16="http://schemas.microsoft.com/office/drawing/2014/main" id="{7F7834EB-AE2E-47C6-8DF3-CFA32BCC118E}"/>
+                <a16:creationId xmlns:a16="http://schemas.microsoft.com/office/drawing/2014/main" id="{A7342C08-12E8-4EC8-A08F-44954B64C3C1}"/>
               </a:ext>
             </a:extLst>
           </p:cNvPr>
@@ -2954,7 +2949,7 @@
           <p:cNvPr id="14" name="">
             <a:extLst xmlns:a="http://schemas.openxmlformats.org/drawingml/2006/main">
               <a:ext uri="{FF2B5EF4-FFF2-40B4-BE49-F238E27FC236}">
-                <a16:creationId xmlns:a16="http://schemas.microsoft.com/office/drawing/2014/main" id="{88F7C963-0229-4CD0-B29D-C0E299477C5B}"/>
+                <a16:creationId xmlns:a16="http://schemas.microsoft.com/office/drawing/2014/main" id="{0D30ED82-16EC-4299-841B-FAD257DE0810}"/>
               </a:ext>
             </a:extLst>
           </p:cNvPr>
@@ -3004,7 +2999,7 @@
           <p:cNvPr id="15" name="">
             <a:extLst xmlns:a="http://schemas.openxmlformats.org/drawingml/2006/main">
               <a:ext uri="{FF2B5EF4-FFF2-40B4-BE49-F238E27FC236}">
-                <a16:creationId xmlns:a16="http://schemas.microsoft.com/office/drawing/2014/main" id="{8D4B838C-0B57-457D-9BB0-87FC36D04DFE}"/>
+                <a16:creationId xmlns:a16="http://schemas.microsoft.com/office/drawing/2014/main" id="{85721BEE-0B57-476E-9C7F-EDB5966EC335}"/>
               </a:ext>
             </a:extLst>
           </p:cNvPr>
@@ -3058,7 +3053,7 @@
           <p:cNvPr id="16" name="">
             <a:extLst xmlns:a="http://schemas.openxmlformats.org/drawingml/2006/main">
               <a:ext uri="{FF2B5EF4-FFF2-40B4-BE49-F238E27FC236}">
-                <a16:creationId xmlns:a16="http://schemas.microsoft.com/office/drawing/2014/main" id="{78EC445C-7A60-45C5-B582-8577C50DA772}"/>
+                <a16:creationId xmlns:a16="http://schemas.microsoft.com/office/drawing/2014/main" id="{B19EE527-391B-4116-A1C6-40CF1396DC5B}"/>
               </a:ext>
             </a:extLst>
           </p:cNvPr>
@@ -3108,7 +3103,7 @@
           <p:cNvPr id="17" name="">
             <a:extLst xmlns:a="http://schemas.openxmlformats.org/drawingml/2006/main">
               <a:ext uri="{FF2B5EF4-FFF2-40B4-BE49-F238E27FC236}">
-                <a16:creationId xmlns:a16="http://schemas.microsoft.com/office/drawing/2014/main" id="{2E7C5689-CDD2-40F3-A405-7384D859A606}"/>
+                <a16:creationId xmlns:a16="http://schemas.microsoft.com/office/drawing/2014/main" id="{A89E0BE2-7C46-4360-A3DA-659E3C16FB42}"/>
               </a:ext>
             </a:extLst>
           </p:cNvPr>
@@ -3158,7 +3153,7 @@
           <p:cNvPr id="18" name="">
             <a:extLst xmlns:a="http://schemas.openxmlformats.org/drawingml/2006/main">
               <a:ext uri="{FF2B5EF4-FFF2-40B4-BE49-F238E27FC236}">
-                <a16:creationId xmlns:a16="http://schemas.microsoft.com/office/drawing/2014/main" id="{68EE5DD9-58F5-4AC9-8B2D-20B4A081E676}"/>
+                <a16:creationId xmlns:a16="http://schemas.microsoft.com/office/drawing/2014/main" id="{818C34B7-BDE3-419E-87A4-B40B31F79E21}"/>
               </a:ext>
             </a:extLst>
           </p:cNvPr>
@@ -3212,7 +3207,7 @@
           <p:cNvPr id="19" name="">
             <a:extLst xmlns:a="http://schemas.openxmlformats.org/drawingml/2006/main">
               <a:ext uri="{FF2B5EF4-FFF2-40B4-BE49-F238E27FC236}">
-                <a16:creationId xmlns:a16="http://schemas.microsoft.com/office/drawing/2014/main" id="{7AA38B22-B471-4654-B3F6-F33E3FBB89E3}"/>
+                <a16:creationId xmlns:a16="http://schemas.microsoft.com/office/drawing/2014/main" id="{89EE628E-BCEB-40A3-9602-40101B5785A8}"/>
               </a:ext>
             </a:extLst>
           </p:cNvPr>
@@ -3262,7 +3257,7 @@
           <p:cNvPr id="20" name="">
             <a:extLst xmlns:a="http://schemas.openxmlformats.org/drawingml/2006/main">
               <a:ext uri="{FF2B5EF4-FFF2-40B4-BE49-F238E27FC236}">
-                <a16:creationId xmlns:a16="http://schemas.microsoft.com/office/drawing/2014/main" id="{826DEFFF-EEAF-42FF-A09A-E0FF98C54A41}"/>
+                <a16:creationId xmlns:a16="http://schemas.microsoft.com/office/drawing/2014/main" id="{01420CE0-3F82-463B-85C9-90A2598119A1}"/>
               </a:ext>
             </a:extLst>
           </p:cNvPr>
@@ -3310,7 +3305,7 @@
     </p:spTree>
     <p:extLst>
       <p:ext uri="{BB962C8B-B14F-4D97-AF65-F5344CB8AC3E}">
-        <p14:creationId xmlns:p14="http://schemas.microsoft.com/office/powerpoint/2010/main" val="947331160"/>
+        <p14:creationId xmlns:p14="http://schemas.microsoft.com/office/powerpoint/2010/main" val="619412190"/>
       </p:ext>
     </p:extLst>
   </p:cSld>
@@ -3341,7 +3336,7 @@
           <p:cNvPr id="35" name="">
             <a:extLst xmlns:a="http://schemas.openxmlformats.org/drawingml/2006/main">
               <a:ext uri="{FF2B5EF4-FFF2-40B4-BE49-F238E27FC236}">
-                <a16:creationId xmlns:a16="http://schemas.microsoft.com/office/drawing/2014/main" id="{24812165-C0BB-414B-8D9E-DE0457A0DC88}"/>
+                <a16:creationId xmlns:a16="http://schemas.microsoft.com/office/drawing/2014/main" id="{F03ABDB9-3C5C-48F8-914E-EFAF961CF3BE}"/>
               </a:ext>
             </a:extLst>
           </p:cNvPr>
@@ -3372,7 +3367,7 @@
           <p:cNvPr id="2" name="">
             <a:extLst xmlns:a="http://schemas.openxmlformats.org/drawingml/2006/main">
               <a:ext uri="{FF2B5EF4-FFF2-40B4-BE49-F238E27FC236}">
-                <a16:creationId xmlns:a16="http://schemas.microsoft.com/office/drawing/2014/main" id="{D4F178FC-A8BC-44D0-95C8-833683BFB71D}"/>
+                <a16:creationId xmlns:a16="http://schemas.microsoft.com/office/drawing/2014/main" id="{C08F2E86-7D85-403E-8FB0-23557823AF09}"/>
               </a:ext>
             </a:extLst>
           </p:cNvPr>
@@ -3422,7 +3417,7 @@
           <p:cNvPr id="3" name="">
             <a:extLst xmlns:a="http://schemas.openxmlformats.org/drawingml/2006/main">
               <a:ext uri="{FF2B5EF4-FFF2-40B4-BE49-F238E27FC236}">
-                <a16:creationId xmlns:a16="http://schemas.microsoft.com/office/drawing/2014/main" id="{66524667-D00E-4E22-BAFB-FE86DEA8635A}"/>
+                <a16:creationId xmlns:a16="http://schemas.microsoft.com/office/drawing/2014/main" id="{7BB163C0-74B2-4517-8D7A-72A99E55D55E}"/>
               </a:ext>
             </a:extLst>
           </p:cNvPr>
@@ -3472,7 +3467,7 @@
           <p:cNvPr id="4" name="">
             <a:extLst xmlns:a="http://schemas.openxmlformats.org/drawingml/2006/main">
               <a:ext uri="{FF2B5EF4-FFF2-40B4-BE49-F238E27FC236}">
-                <a16:creationId xmlns:a16="http://schemas.microsoft.com/office/drawing/2014/main" id="{E3DA2DD3-59FD-4310-89D3-BB7C0C7FF799}"/>
+                <a16:creationId xmlns:a16="http://schemas.microsoft.com/office/drawing/2014/main" id="{03D2AA67-98BE-4D55-9202-C19E25E9EA0E}"/>
               </a:ext>
             </a:extLst>
           </p:cNvPr>
@@ -3503,7 +3498,7 @@
           <p:cNvPr id="5" name="">
             <a:extLst xmlns:a="http://schemas.openxmlformats.org/drawingml/2006/main">
               <a:ext uri="{FF2B5EF4-FFF2-40B4-BE49-F238E27FC236}">
-                <a16:creationId xmlns:a16="http://schemas.microsoft.com/office/drawing/2014/main" id="{53372E4B-5127-471D-A133-D4ED4180E70B}"/>
+                <a16:creationId xmlns:a16="http://schemas.microsoft.com/office/drawing/2014/main" id="{C06760A3-B4A8-4747-98DF-771730E5A8E2}"/>
               </a:ext>
             </a:extLst>
           </p:cNvPr>
@@ -3553,7 +3548,7 @@
           <p:cNvPr id="6" name="">
             <a:extLst xmlns:a="http://schemas.openxmlformats.org/drawingml/2006/main">
               <a:ext uri="{FF2B5EF4-FFF2-40B4-BE49-F238E27FC236}">
-                <a16:creationId xmlns:a16="http://schemas.microsoft.com/office/drawing/2014/main" id="{DD32B028-5B1A-45F0-B887-FAAF32B8F258}"/>
+                <a16:creationId xmlns:a16="http://schemas.microsoft.com/office/drawing/2014/main" id="{ED2FFC97-93B6-4AD4-8047-079AF656D2EF}"/>
               </a:ext>
             </a:extLst>
           </p:cNvPr>
@@ -3603,7 +3598,7 @@
           <p:cNvPr id="7" name="">
             <a:extLst xmlns:a="http://schemas.openxmlformats.org/drawingml/2006/main">
               <a:ext uri="{FF2B5EF4-FFF2-40B4-BE49-F238E27FC236}">
-                <a16:creationId xmlns:a16="http://schemas.microsoft.com/office/drawing/2014/main" id="{2975D596-9AA9-4203-A69E-8F8FAA81EEB6}"/>
+                <a16:creationId xmlns:a16="http://schemas.microsoft.com/office/drawing/2014/main" id="{274633B0-869F-4540-930C-45DD9DEFDE7C}"/>
               </a:ext>
             </a:extLst>
           </p:cNvPr>
@@ -3634,7 +3629,7 @@
           <p:cNvPr id="8" name="">
             <a:extLst xmlns:a="http://schemas.openxmlformats.org/drawingml/2006/main">
               <a:ext uri="{FF2B5EF4-FFF2-40B4-BE49-F238E27FC236}">
-                <a16:creationId xmlns:a16="http://schemas.microsoft.com/office/drawing/2014/main" id="{59525285-C946-44C5-95F2-E1C67F403086}"/>
+                <a16:creationId xmlns:a16="http://schemas.microsoft.com/office/drawing/2014/main" id="{7004CE36-BCC2-4CD3-81DC-7F99AFA3A831}"/>
               </a:ext>
             </a:extLst>
           </p:cNvPr>
@@ -3665,7 +3660,7 @@
           <p:cNvPr id="9" name="">
             <a:extLst xmlns:a="http://schemas.openxmlformats.org/drawingml/2006/main">
               <a:ext uri="{FF2B5EF4-FFF2-40B4-BE49-F238E27FC236}">
-                <a16:creationId xmlns:a16="http://schemas.microsoft.com/office/drawing/2014/main" id="{E0F479FB-3281-40A6-A693-C6C60B73A6BC}"/>
+                <a16:creationId xmlns:a16="http://schemas.microsoft.com/office/drawing/2014/main" id="{2BD77333-D89C-4F10-9827-BCF9F0A1A2FB}"/>
               </a:ext>
             </a:extLst>
           </p:cNvPr>
@@ -3696,7 +3691,7 @@
           <p:cNvPr id="10" name="">
             <a:extLst xmlns:a="http://schemas.openxmlformats.org/drawingml/2006/main">
               <a:ext uri="{FF2B5EF4-FFF2-40B4-BE49-F238E27FC236}">
-                <a16:creationId xmlns:a16="http://schemas.microsoft.com/office/drawing/2014/main" id="{FA15C89D-F45F-479F-A325-4B8D1AFE7A62}"/>
+                <a16:creationId xmlns:a16="http://schemas.microsoft.com/office/drawing/2014/main" id="{9D5A8904-3675-4B32-9D89-6C8F282F437C}"/>
               </a:ext>
             </a:extLst>
           </p:cNvPr>
@@ -3727,7 +3722,7 @@
           <p:cNvPr id="11" name="">
             <a:extLst xmlns:a="http://schemas.openxmlformats.org/drawingml/2006/main">
               <a:ext uri="{FF2B5EF4-FFF2-40B4-BE49-F238E27FC236}">
-                <a16:creationId xmlns:a16="http://schemas.microsoft.com/office/drawing/2014/main" id="{DCD2CC48-D44E-4B30-B3E3-4D11D9C4E8B9}"/>
+                <a16:creationId xmlns:a16="http://schemas.microsoft.com/office/drawing/2014/main" id="{A96C5997-F292-4F1F-A9A2-C16FD4442CD9}"/>
               </a:ext>
             </a:extLst>
           </p:cNvPr>
@@ -3777,7 +3772,7 @@
           <p:cNvPr id="12" name="">
             <a:extLst xmlns:a="http://schemas.openxmlformats.org/drawingml/2006/main">
               <a:ext uri="{FF2B5EF4-FFF2-40B4-BE49-F238E27FC236}">
-                <a16:creationId xmlns:a16="http://schemas.microsoft.com/office/drawing/2014/main" id="{85787DC9-27BA-4F46-B3D3-457B9CBD4F74}"/>
+                <a16:creationId xmlns:a16="http://schemas.microsoft.com/office/drawing/2014/main" id="{777DC01C-BC6E-4922-BFCD-FBAC42813FDC}"/>
               </a:ext>
             </a:extLst>
           </p:cNvPr>
@@ -3808,7 +3803,7 @@
           <p:cNvPr id="13" name="">
             <a:extLst xmlns:a="http://schemas.openxmlformats.org/drawingml/2006/main">
               <a:ext uri="{FF2B5EF4-FFF2-40B4-BE49-F238E27FC236}">
-                <a16:creationId xmlns:a16="http://schemas.microsoft.com/office/drawing/2014/main" id="{EDB7C63B-EBEB-414D-97DA-21479FC7EADE}"/>
+                <a16:creationId xmlns:a16="http://schemas.microsoft.com/office/drawing/2014/main" id="{B9E6C9D7-39B5-4CDA-B760-1984FD6C9ED4}"/>
               </a:ext>
             </a:extLst>
           </p:cNvPr>
@@ -3858,7 +3853,7 @@
           <p:cNvPr id="14" name="">
             <a:extLst xmlns:a="http://schemas.openxmlformats.org/drawingml/2006/main">
               <a:ext uri="{FF2B5EF4-FFF2-40B4-BE49-F238E27FC236}">
-                <a16:creationId xmlns:a16="http://schemas.microsoft.com/office/drawing/2014/main" id="{68C0A035-C492-4812-BA5E-0C5A82A5DAAA}"/>
+                <a16:creationId xmlns:a16="http://schemas.microsoft.com/office/drawing/2014/main" id="{94AF1D0F-76DD-43D3-A97A-1D114B15440B}"/>
               </a:ext>
             </a:extLst>
           </p:cNvPr>
@@ -3908,7 +3903,7 @@
           <p:cNvPr id="15" name="">
             <a:extLst xmlns:a="http://schemas.openxmlformats.org/drawingml/2006/main">
               <a:ext uri="{FF2B5EF4-FFF2-40B4-BE49-F238E27FC236}">
-                <a16:creationId xmlns:a16="http://schemas.microsoft.com/office/drawing/2014/main" id="{B78A1D50-C48C-4844-AEC1-3601A9B745F4}"/>
+                <a16:creationId xmlns:a16="http://schemas.microsoft.com/office/drawing/2014/main" id="{0AA020E1-AF94-4AA7-AC1C-80CD5ED3D2B3}"/>
               </a:ext>
             </a:extLst>
           </p:cNvPr>
@@ -3958,7 +3953,7 @@
           <p:cNvPr id="16" name="">
             <a:extLst xmlns:a="http://schemas.openxmlformats.org/drawingml/2006/main">
               <a:ext uri="{FF2B5EF4-FFF2-40B4-BE49-F238E27FC236}">
-                <a16:creationId xmlns:a16="http://schemas.microsoft.com/office/drawing/2014/main" id="{B5E21011-3CD7-4938-A0C9-6FF1A07083A0}"/>
+                <a16:creationId xmlns:a16="http://schemas.microsoft.com/office/drawing/2014/main" id="{218B661F-96C5-4936-B835-37DE34654B6F}"/>
               </a:ext>
             </a:extLst>
           </p:cNvPr>
@@ -3989,7 +3984,7 @@
           <p:cNvPr id="17" name="">
             <a:extLst xmlns:a="http://schemas.openxmlformats.org/drawingml/2006/main">
               <a:ext uri="{FF2B5EF4-FFF2-40B4-BE49-F238E27FC236}">
-                <a16:creationId xmlns:a16="http://schemas.microsoft.com/office/drawing/2014/main" id="{924DD27E-0B05-47C7-B813-822EEB5A2F81}"/>
+                <a16:creationId xmlns:a16="http://schemas.microsoft.com/office/drawing/2014/main" id="{295614F9-ABEB-4A88-AC6C-EF6AB8EECA32}"/>
               </a:ext>
             </a:extLst>
           </p:cNvPr>
@@ -4039,7 +4034,7 @@
           <p:cNvPr id="18" name="">
             <a:extLst xmlns:a="http://schemas.openxmlformats.org/drawingml/2006/main">
               <a:ext uri="{FF2B5EF4-FFF2-40B4-BE49-F238E27FC236}">
-                <a16:creationId xmlns:a16="http://schemas.microsoft.com/office/drawing/2014/main" id="{0F42F92F-8D26-4B56-925F-F9BD0BF35B10}"/>
+                <a16:creationId xmlns:a16="http://schemas.microsoft.com/office/drawing/2014/main" id="{D2310EF3-0679-405A-A83B-CC33D993DD6E}"/>
               </a:ext>
             </a:extLst>
           </p:cNvPr>
@@ -4089,7 +4084,7 @@
           <p:cNvPr id="19" name="">
             <a:extLst xmlns:a="http://schemas.openxmlformats.org/drawingml/2006/main">
               <a:ext uri="{FF2B5EF4-FFF2-40B4-BE49-F238E27FC236}">
-                <a16:creationId xmlns:a16="http://schemas.microsoft.com/office/drawing/2014/main" id="{1D43F9A1-0270-47AC-8DAE-5F99E38AD913}"/>
+                <a16:creationId xmlns:a16="http://schemas.microsoft.com/office/drawing/2014/main" id="{9005FCAA-B0AC-4535-9178-71952331283A}"/>
               </a:ext>
             </a:extLst>
           </p:cNvPr>
@@ -4139,7 +4134,7 @@
           <p:cNvPr id="20" name="">
             <a:extLst xmlns:a="http://schemas.openxmlformats.org/drawingml/2006/main">
               <a:ext uri="{FF2B5EF4-FFF2-40B4-BE49-F238E27FC236}">
-                <a16:creationId xmlns:a16="http://schemas.microsoft.com/office/drawing/2014/main" id="{5A94660E-FF13-4B62-950F-0FEDBF7B4E5F}"/>
+                <a16:creationId xmlns:a16="http://schemas.microsoft.com/office/drawing/2014/main" id="{DEDEFCDE-23C2-4762-8949-156F48BA4166}"/>
               </a:ext>
             </a:extLst>
           </p:cNvPr>
@@ -4170,7 +4165,7 @@
           <p:cNvPr id="21" name="">
             <a:extLst xmlns:a="http://schemas.openxmlformats.org/drawingml/2006/main">
               <a:ext uri="{FF2B5EF4-FFF2-40B4-BE49-F238E27FC236}">
-                <a16:creationId xmlns:a16="http://schemas.microsoft.com/office/drawing/2014/main" id="{709BFB62-9D84-4B8A-B9B7-EE9C937B308D}"/>
+                <a16:creationId xmlns:a16="http://schemas.microsoft.com/office/drawing/2014/main" id="{5993BA99-50C5-401D-A2F0-8D0DCC94B5C8}"/>
               </a:ext>
             </a:extLst>
           </p:cNvPr>
@@ -4220,7 +4215,7 @@
           <p:cNvPr id="22" name="">
             <a:extLst xmlns:a="http://schemas.openxmlformats.org/drawingml/2006/main">
               <a:ext uri="{FF2B5EF4-FFF2-40B4-BE49-F238E27FC236}">
-                <a16:creationId xmlns:a16="http://schemas.microsoft.com/office/drawing/2014/main" id="{98F17690-FCE8-4F42-B7CE-65B1D092A8C5}"/>
+                <a16:creationId xmlns:a16="http://schemas.microsoft.com/office/drawing/2014/main" id="{5DAF1F8D-151A-4BF1-809B-6E6F836333C1}"/>
               </a:ext>
             </a:extLst>
           </p:cNvPr>
@@ -4270,7 +4265,7 @@
           <p:cNvPr id="23" name="">
             <a:extLst xmlns:a="http://schemas.openxmlformats.org/drawingml/2006/main">
               <a:ext uri="{FF2B5EF4-FFF2-40B4-BE49-F238E27FC236}">
-                <a16:creationId xmlns:a16="http://schemas.microsoft.com/office/drawing/2014/main" id="{E89F399F-3A0D-47DA-8EF5-12F9451A5C95}"/>
+                <a16:creationId xmlns:a16="http://schemas.microsoft.com/office/drawing/2014/main" id="{214EBF8D-AC53-41EC-A3E7-9BBF7D61CE1A}"/>
               </a:ext>
             </a:extLst>
           </p:cNvPr>
@@ -4320,7 +4315,7 @@
           <p:cNvPr id="24" name="">
             <a:extLst xmlns:a="http://schemas.openxmlformats.org/drawingml/2006/main">
               <a:ext uri="{FF2B5EF4-FFF2-40B4-BE49-F238E27FC236}">
-                <a16:creationId xmlns:a16="http://schemas.microsoft.com/office/drawing/2014/main" id="{CB2112F9-6FE7-4916-B821-96236681A3F1}"/>
+                <a16:creationId xmlns:a16="http://schemas.microsoft.com/office/drawing/2014/main" id="{34AD843E-2134-4200-8A0D-0406343D4B2F}"/>
               </a:ext>
             </a:extLst>
           </p:cNvPr>
@@ -4351,7 +4346,7 @@
           <p:cNvPr id="25" name="">
             <a:extLst xmlns:a="http://schemas.openxmlformats.org/drawingml/2006/main">
               <a:ext uri="{FF2B5EF4-FFF2-40B4-BE49-F238E27FC236}">
-                <a16:creationId xmlns:a16="http://schemas.microsoft.com/office/drawing/2014/main" id="{FAC9691B-0EDF-4525-BA50-1903E88DB198}"/>
+                <a16:creationId xmlns:a16="http://schemas.microsoft.com/office/drawing/2014/main" id="{32342833-1FE7-40E0-A8F6-511231BE434E}"/>
               </a:ext>
             </a:extLst>
           </p:cNvPr>
@@ -4401,7 +4396,7 @@
           <p:cNvPr id="26" name="">
             <a:extLst xmlns:a="http://schemas.openxmlformats.org/drawingml/2006/main">
               <a:ext uri="{FF2B5EF4-FFF2-40B4-BE49-F238E27FC236}">
-                <a16:creationId xmlns:a16="http://schemas.microsoft.com/office/drawing/2014/main" id="{67D3B0BD-F01B-4260-BA25-510A40156194}"/>
+                <a16:creationId xmlns:a16="http://schemas.microsoft.com/office/drawing/2014/main" id="{FD5A2286-7BD3-4A73-B9D0-0A62FBFFE2EF}"/>
               </a:ext>
             </a:extLst>
           </p:cNvPr>
@@ -4451,7 +4446,7 @@
           <p:cNvPr id="27" name="">
             <a:extLst xmlns:a="http://schemas.openxmlformats.org/drawingml/2006/main">
               <a:ext uri="{FF2B5EF4-FFF2-40B4-BE49-F238E27FC236}">
-                <a16:creationId xmlns:a16="http://schemas.microsoft.com/office/drawing/2014/main" id="{D404C85B-A85B-473A-B498-83C0C6BC8FB7}"/>
+                <a16:creationId xmlns:a16="http://schemas.microsoft.com/office/drawing/2014/main" id="{70979B49-36A9-4E7C-858D-22286870C4FA}"/>
               </a:ext>
             </a:extLst>
           </p:cNvPr>
@@ -4501,7 +4496,7 @@
           <p:cNvPr id="28" name="">
             <a:extLst xmlns:a="http://schemas.openxmlformats.org/drawingml/2006/main">
               <a:ext uri="{FF2B5EF4-FFF2-40B4-BE49-F238E27FC236}">
-                <a16:creationId xmlns:a16="http://schemas.microsoft.com/office/drawing/2014/main" id="{C39C8901-7789-4C1C-9262-428B910D629A}"/>
+                <a16:creationId xmlns:a16="http://schemas.microsoft.com/office/drawing/2014/main" id="{7E2B4CE6-F82F-493A-A6D6-E76675215684}"/>
               </a:ext>
             </a:extLst>
           </p:cNvPr>
@@ -4532,7 +4527,7 @@
           <p:cNvPr id="29" name="">
             <a:extLst xmlns:a="http://schemas.openxmlformats.org/drawingml/2006/main">
               <a:ext uri="{FF2B5EF4-FFF2-40B4-BE49-F238E27FC236}">
-                <a16:creationId xmlns:a16="http://schemas.microsoft.com/office/drawing/2014/main" id="{0D23EAEC-1F34-4E75-BAB6-668A5135B8D7}"/>
+                <a16:creationId xmlns:a16="http://schemas.microsoft.com/office/drawing/2014/main" id="{FC509ACB-E6CD-4E92-B43F-5C14FEFB1D27}"/>
               </a:ext>
             </a:extLst>
           </p:cNvPr>
@@ -4582,7 +4577,7 @@
           <p:cNvPr id="30" name="">
             <a:extLst xmlns:a="http://schemas.openxmlformats.org/drawingml/2006/main">
               <a:ext uri="{FF2B5EF4-FFF2-40B4-BE49-F238E27FC236}">
-                <a16:creationId xmlns:a16="http://schemas.microsoft.com/office/drawing/2014/main" id="{EFEEF2EC-2FF4-4438-BEC2-4B3B2B00F182}"/>
+                <a16:creationId xmlns:a16="http://schemas.microsoft.com/office/drawing/2014/main" id="{ADB101BE-719D-4E4B-8CD6-AD8B7AEF6708}"/>
               </a:ext>
             </a:extLst>
           </p:cNvPr>
@@ -4632,7 +4627,7 @@
           <p:cNvPr id="31" name="">
             <a:extLst xmlns:a="http://schemas.openxmlformats.org/drawingml/2006/main">
               <a:ext uri="{FF2B5EF4-FFF2-40B4-BE49-F238E27FC236}">
-                <a16:creationId xmlns:a16="http://schemas.microsoft.com/office/drawing/2014/main" id="{67C37244-E219-4D04-B1F4-D5D07DAE0F82}"/>
+                <a16:creationId xmlns:a16="http://schemas.microsoft.com/office/drawing/2014/main" id="{7C9ACC57-93A7-4D16-B59B-9440817356C1}"/>
               </a:ext>
             </a:extLst>
           </p:cNvPr>
@@ -4667,7 +4662,7 @@
           <p:cNvPr id="32" name="">
             <a:extLst xmlns:a="http://schemas.openxmlformats.org/drawingml/2006/main">
               <a:ext uri="{FF2B5EF4-FFF2-40B4-BE49-F238E27FC236}">
-                <a16:creationId xmlns:a16="http://schemas.microsoft.com/office/drawing/2014/main" id="{86B53CA4-4A90-46AD-9159-1238B4542BEA}"/>
+                <a16:creationId xmlns:a16="http://schemas.microsoft.com/office/drawing/2014/main" id="{05C6737F-02FF-40CC-93A5-A32A034FB665}"/>
               </a:ext>
             </a:extLst>
           </p:cNvPr>
@@ -4717,7 +4712,7 @@
           <p:cNvPr id="33" name="">
             <a:extLst xmlns:a="http://schemas.openxmlformats.org/drawingml/2006/main">
               <a:ext uri="{FF2B5EF4-FFF2-40B4-BE49-F238E27FC236}">
-                <a16:creationId xmlns:a16="http://schemas.microsoft.com/office/drawing/2014/main" id="{32CCC311-65D3-4B24-A40A-459A46BF173C}"/>
+                <a16:creationId xmlns:a16="http://schemas.microsoft.com/office/drawing/2014/main" id="{AAA27B74-FB7A-4B1C-830E-75E3D1992E18}"/>
               </a:ext>
             </a:extLst>
           </p:cNvPr>
@@ -4767,7 +4762,7 @@
           <p:cNvPr id="34" name="">
             <a:extLst xmlns:a="http://schemas.openxmlformats.org/drawingml/2006/main">
               <a:ext uri="{FF2B5EF4-FFF2-40B4-BE49-F238E27FC236}">
-                <a16:creationId xmlns:a16="http://schemas.microsoft.com/office/drawing/2014/main" id="{5C60B05D-2622-4E65-A8DA-D31A62FAE177}"/>
+                <a16:creationId xmlns:a16="http://schemas.microsoft.com/office/drawing/2014/main" id="{0D57B10A-4639-4A72-9B4C-5C11CEBE2EB1}"/>
               </a:ext>
             </a:extLst>
           </p:cNvPr>
@@ -4819,7 +4814,7 @@
     </p:spTree>
     <p:extLst>
       <p:ext uri="{BB962C8B-B14F-4D97-AF65-F5344CB8AC3E}">
-        <p14:creationId xmlns:p14="http://schemas.microsoft.com/office/powerpoint/2010/main" val="824007861"/>
+        <p14:creationId xmlns:p14="http://schemas.microsoft.com/office/powerpoint/2010/main" val="447386516"/>
       </p:ext>
     </p:extLst>
   </p:cSld>
@@ -4850,7 +4845,7 @@
           <p:cNvPr id="26" name="">
             <a:extLst xmlns:a="http://schemas.openxmlformats.org/drawingml/2006/main">
               <a:ext uri="{FF2B5EF4-FFF2-40B4-BE49-F238E27FC236}">
-                <a16:creationId xmlns:a16="http://schemas.microsoft.com/office/drawing/2014/main" id="{3C0FF9AD-34A7-4D08-A45F-A5BE9608CC5E}"/>
+                <a16:creationId xmlns:a16="http://schemas.microsoft.com/office/drawing/2014/main" id="{5C2B529C-3745-4A5E-8631-19B28AC854BB}"/>
               </a:ext>
             </a:extLst>
           </p:cNvPr>
@@ -4881,7 +4876,7 @@
           <p:cNvPr id="2" name="">
             <a:extLst xmlns:a="http://schemas.openxmlformats.org/drawingml/2006/main">
               <a:ext uri="{FF2B5EF4-FFF2-40B4-BE49-F238E27FC236}">
-                <a16:creationId xmlns:a16="http://schemas.microsoft.com/office/drawing/2014/main" id="{4EF98992-3DF8-459B-B482-D2B0B0A2AEF9}"/>
+                <a16:creationId xmlns:a16="http://schemas.microsoft.com/office/drawing/2014/main" id="{01DDC123-8326-4DC7-AC93-C042412C83F7}"/>
               </a:ext>
             </a:extLst>
           </p:cNvPr>
@@ -4921,7 +4916,7 @@
                   <a:srgbClr val="0F766E"/>
                 </a:solidFill>
               </a:rPr>
-              <a:t>BOUNDED AGENT LOOP</a:t>
+              <a:t>BOUNDED AGENT LOOP · CACHED REHEARSAL</a:t>
             </a:r>
           </a:p>
         </p:txBody>
@@ -4931,7 +4926,7 @@
           <p:cNvPr id="3" name="">
             <a:extLst xmlns:a="http://schemas.openxmlformats.org/drawingml/2006/main">
               <a:ext uri="{FF2B5EF4-FFF2-40B4-BE49-F238E27FC236}">
-                <a16:creationId xmlns:a16="http://schemas.microsoft.com/office/drawing/2014/main" id="{8DCBE73D-0AA5-48CF-9092-6BCC52EA31DD}"/>
+                <a16:creationId xmlns:a16="http://schemas.microsoft.com/office/drawing/2014/main" id="{15CD897A-8CEE-43A5-A15C-82F0AB7BCA19}"/>
               </a:ext>
             </a:extLst>
           </p:cNvPr>
@@ -4981,7 +4976,7 @@
           <p:cNvPr id="4" name="">
             <a:extLst xmlns:a="http://schemas.openxmlformats.org/drawingml/2006/main">
               <a:ext uri="{FF2B5EF4-FFF2-40B4-BE49-F238E27FC236}">
-                <a16:creationId xmlns:a16="http://schemas.microsoft.com/office/drawing/2014/main" id="{58E45A49-598C-40B6-B7B5-7C0AFEB5E62D}"/>
+                <a16:creationId xmlns:a16="http://schemas.microsoft.com/office/drawing/2014/main" id="{DB8E0A9B-6F2F-4325-BC48-D2DCBABE4748}"/>
               </a:ext>
             </a:extLst>
           </p:cNvPr>
@@ -5012,7 +5007,7 @@
           <p:cNvPr id="5" name="">
             <a:extLst xmlns:a="http://schemas.openxmlformats.org/drawingml/2006/main">
               <a:ext uri="{FF2B5EF4-FFF2-40B4-BE49-F238E27FC236}">
-                <a16:creationId xmlns:a16="http://schemas.microsoft.com/office/drawing/2014/main" id="{1857DF46-8DB0-4F38-B905-577DA162A7A9}"/>
+                <a16:creationId xmlns:a16="http://schemas.microsoft.com/office/drawing/2014/main" id="{FE751AB5-A163-497E-8D40-788BAC86035D}"/>
               </a:ext>
             </a:extLst>
           </p:cNvPr>
@@ -5062,7 +5057,7 @@
           <p:cNvPr id="6" name="">
             <a:extLst xmlns:a="http://schemas.openxmlformats.org/drawingml/2006/main">
               <a:ext uri="{FF2B5EF4-FFF2-40B4-BE49-F238E27FC236}">
-                <a16:creationId xmlns:a16="http://schemas.microsoft.com/office/drawing/2014/main" id="{67AD6EC5-C7B0-4EA9-A14E-FDB084CD0CC2}"/>
+                <a16:creationId xmlns:a16="http://schemas.microsoft.com/office/drawing/2014/main" id="{67B71C04-27DD-4D22-AEBF-10A9625CAE48}"/>
               </a:ext>
             </a:extLst>
           </p:cNvPr>
@@ -5102,7 +5097,7 @@
                   <a:srgbClr val="102A43"/>
                 </a:solidFill>
               </a:rPr>
-              <a:t>One targeted cycle closes coverage — or stops</a:t>
+              <a:t>Coverage satisfied on the first bounded pass</a:t>
             </a:r>
           </a:p>
         </p:txBody>
@@ -5112,7 +5107,7 @@
           <p:cNvPr id="7" name="">
             <a:extLst xmlns:a="http://schemas.openxmlformats.org/drawingml/2006/main">
               <a:ext uri="{FF2B5EF4-FFF2-40B4-BE49-F238E27FC236}">
-                <a16:creationId xmlns:a16="http://schemas.microsoft.com/office/drawing/2014/main" id="{4766469B-A5F0-4B64-A178-A18CE317DC60}"/>
+                <a16:creationId xmlns:a16="http://schemas.microsoft.com/office/drawing/2014/main" id="{132EB52E-A8E1-4BEA-8D28-CFAFE6DB7207}"/>
               </a:ext>
             </a:extLst>
           </p:cNvPr>
@@ -5143,7 +5138,7 @@
           <p:cNvPr id="8" name="">
             <a:extLst xmlns:a="http://schemas.openxmlformats.org/drawingml/2006/main">
               <a:ext uri="{FF2B5EF4-FFF2-40B4-BE49-F238E27FC236}">
-                <a16:creationId xmlns:a16="http://schemas.microsoft.com/office/drawing/2014/main" id="{D8310F1D-6ED4-43F1-93D0-52FD02755321}"/>
+                <a16:creationId xmlns:a16="http://schemas.microsoft.com/office/drawing/2014/main" id="{810ECCBA-E508-4AC4-9951-D9EECC437DD5}"/>
               </a:ext>
             </a:extLst>
           </p:cNvPr>
@@ -5197,7 +5192,7 @@
           <p:cNvPr id="9" name="">
             <a:extLst xmlns:a="http://schemas.openxmlformats.org/drawingml/2006/main">
               <a:ext uri="{FF2B5EF4-FFF2-40B4-BE49-F238E27FC236}">
-                <a16:creationId xmlns:a16="http://schemas.microsoft.com/office/drawing/2014/main" id="{588A7C09-8621-4124-8474-A8B83E9F9AAC}"/>
+                <a16:creationId xmlns:a16="http://schemas.microsoft.com/office/drawing/2014/main" id="{6B16FA6D-FA7C-4BB7-8D50-F18D01C018D8}"/>
               </a:ext>
             </a:extLst>
           </p:cNvPr>
@@ -5247,7 +5242,7 @@
           <p:cNvPr id="10" name="">
             <a:extLst xmlns:a="http://schemas.openxmlformats.org/drawingml/2006/main">
               <a:ext uri="{FF2B5EF4-FFF2-40B4-BE49-F238E27FC236}">
-                <a16:creationId xmlns:a16="http://schemas.microsoft.com/office/drawing/2014/main" id="{03C1D3BE-D69E-4F08-BBD3-97644FC58685}"/>
+                <a16:creationId xmlns:a16="http://schemas.microsoft.com/office/drawing/2014/main" id="{19BA494B-182F-4A18-84C6-3FF30E099051}"/>
               </a:ext>
             </a:extLst>
           </p:cNvPr>
@@ -5297,7 +5292,7 @@
           <p:cNvPr id="11" name="">
             <a:extLst xmlns:a="http://schemas.openxmlformats.org/drawingml/2006/main">
               <a:ext uri="{FF2B5EF4-FFF2-40B4-BE49-F238E27FC236}">
-                <a16:creationId xmlns:a16="http://schemas.microsoft.com/office/drawing/2014/main" id="{FE4B311A-84A5-441A-842D-7B78F153A256}"/>
+                <a16:creationId xmlns:a16="http://schemas.microsoft.com/office/drawing/2014/main" id="{82D51392-47F8-4DAB-A02E-023B62723E68}"/>
               </a:ext>
             </a:extLst>
           </p:cNvPr>
@@ -5351,7 +5346,7 @@
           <p:cNvPr id="12" name="">
             <a:extLst xmlns:a="http://schemas.openxmlformats.org/drawingml/2006/main">
               <a:ext uri="{FF2B5EF4-FFF2-40B4-BE49-F238E27FC236}">
-                <a16:creationId xmlns:a16="http://schemas.microsoft.com/office/drawing/2014/main" id="{9E3FF41A-1D57-4168-8908-3A341BFB9D3D}"/>
+                <a16:creationId xmlns:a16="http://schemas.microsoft.com/office/drawing/2014/main" id="{95241CDB-341B-4E6B-B49D-367B9C352228}"/>
               </a:ext>
             </a:extLst>
           </p:cNvPr>
@@ -5401,7 +5396,7 @@
           <p:cNvPr id="13" name="">
             <a:extLst xmlns:a="http://schemas.openxmlformats.org/drawingml/2006/main">
               <a:ext uri="{FF2B5EF4-FFF2-40B4-BE49-F238E27FC236}">
-                <a16:creationId xmlns:a16="http://schemas.microsoft.com/office/drawing/2014/main" id="{2685BE7C-C1AD-46F2-9BE4-0B55B8A1E2D4}"/>
+                <a16:creationId xmlns:a16="http://schemas.microsoft.com/office/drawing/2014/main" id="{61FB8EC3-E075-42B1-8D83-48F1B762C25E}"/>
               </a:ext>
             </a:extLst>
           </p:cNvPr>
@@ -5451,7 +5446,7 @@
           <p:cNvPr id="14" name="">
             <a:extLst xmlns:a="http://schemas.openxmlformats.org/drawingml/2006/main">
               <a:ext uri="{FF2B5EF4-FFF2-40B4-BE49-F238E27FC236}">
-                <a16:creationId xmlns:a16="http://schemas.microsoft.com/office/drawing/2014/main" id="{E1904B8E-9150-426E-9437-C4FC8B60BDDB}"/>
+                <a16:creationId xmlns:a16="http://schemas.microsoft.com/office/drawing/2014/main" id="{ACB2E836-9556-4994-9894-2E51ABDEDBD1}"/>
               </a:ext>
             </a:extLst>
           </p:cNvPr>
@@ -5505,7 +5500,7 @@
           <p:cNvPr id="15" name="">
             <a:extLst xmlns:a="http://schemas.openxmlformats.org/drawingml/2006/main">
               <a:ext uri="{FF2B5EF4-FFF2-40B4-BE49-F238E27FC236}">
-                <a16:creationId xmlns:a16="http://schemas.microsoft.com/office/drawing/2014/main" id="{A4122BF7-3276-460E-AD27-93FD9918C7B0}"/>
+                <a16:creationId xmlns:a16="http://schemas.microsoft.com/office/drawing/2014/main" id="{8BCEF53C-9EE8-4C95-B22A-4C873E832905}"/>
               </a:ext>
             </a:extLst>
           </p:cNvPr>
@@ -5555,7 +5550,7 @@
           <p:cNvPr id="16" name="">
             <a:extLst xmlns:a="http://schemas.openxmlformats.org/drawingml/2006/main">
               <a:ext uri="{FF2B5EF4-FFF2-40B4-BE49-F238E27FC236}">
-                <a16:creationId xmlns:a16="http://schemas.microsoft.com/office/drawing/2014/main" id="{D2BA6DC3-EAAD-426F-9222-DA413DBAB2AA}"/>
+                <a16:creationId xmlns:a16="http://schemas.microsoft.com/office/drawing/2014/main" id="{3EC19B1A-184C-4AE5-9504-742BF40241FC}"/>
               </a:ext>
             </a:extLst>
           </p:cNvPr>
@@ -5605,7 +5600,7 @@
           <p:cNvPr id="17" name="">
             <a:extLst xmlns:a="http://schemas.openxmlformats.org/drawingml/2006/main">
               <a:ext uri="{FF2B5EF4-FFF2-40B4-BE49-F238E27FC236}">
-                <a16:creationId xmlns:a16="http://schemas.microsoft.com/office/drawing/2014/main" id="{ACAD27AB-D92D-4895-B151-609AB241B528}"/>
+                <a16:creationId xmlns:a16="http://schemas.microsoft.com/office/drawing/2014/main" id="{A492FA1D-A27C-4553-860F-59D311D7A045}"/>
               </a:ext>
             </a:extLst>
           </p:cNvPr>
@@ -5659,7 +5654,7 @@
           <p:cNvPr id="18" name="">
             <a:extLst xmlns:a="http://schemas.openxmlformats.org/drawingml/2006/main">
               <a:ext uri="{FF2B5EF4-FFF2-40B4-BE49-F238E27FC236}">
-                <a16:creationId xmlns:a16="http://schemas.microsoft.com/office/drawing/2014/main" id="{B88ADD6A-4061-4766-8ADC-AE5CE6DC6004}"/>
+                <a16:creationId xmlns:a16="http://schemas.microsoft.com/office/drawing/2014/main" id="{04EBC74B-7B44-4363-9AFA-EE43F29E0384}"/>
               </a:ext>
             </a:extLst>
           </p:cNvPr>
@@ -5699,7 +5694,7 @@
                   <a:srgbClr val="0F766E"/>
                 </a:solidFill>
               </a:rPr>
-              <a:t>ADAPT</a:t>
+              <a:t>FREEZE</a:t>
             </a:r>
           </a:p>
         </p:txBody>
@@ -5709,7 +5704,7 @@
           <p:cNvPr id="19" name="">
             <a:extLst xmlns:a="http://schemas.openxmlformats.org/drawingml/2006/main">
               <a:ext uri="{FF2B5EF4-FFF2-40B4-BE49-F238E27FC236}">
-                <a16:creationId xmlns:a16="http://schemas.microsoft.com/office/drawing/2014/main" id="{DD3DF7A7-4D85-422E-A7C4-DC5A2379FA63}"/>
+                <a16:creationId xmlns:a16="http://schemas.microsoft.com/office/drawing/2014/main" id="{F713CBCE-ECFC-44DE-9154-FEE8FAEE475D}"/>
               </a:ext>
             </a:extLst>
           </p:cNvPr>
@@ -5749,7 +5744,7 @@
                   <a:srgbClr val="627D8C"/>
                 </a:solidFill>
               </a:rPr>
-              <a:t>One targeted batch</a:t>
+              <a:t>No adaptive call needed</a:t>
             </a:r>
           </a:p>
         </p:txBody>
@@ -5759,7 +5754,7 @@
           <p:cNvPr id="20" name="">
             <a:extLst xmlns:a="http://schemas.openxmlformats.org/drawingml/2006/main">
               <a:ext uri="{FF2B5EF4-FFF2-40B4-BE49-F238E27FC236}">
-                <a16:creationId xmlns:a16="http://schemas.microsoft.com/office/drawing/2014/main" id="{C7A02D96-B259-47FD-AC43-88D61E61D0B5}"/>
+                <a16:creationId xmlns:a16="http://schemas.microsoft.com/office/drawing/2014/main" id="{A581CF8E-D54F-47E1-9A82-C768DB2AB4E8}"/>
               </a:ext>
             </a:extLst>
           </p:cNvPr>
@@ -5813,7 +5808,7 @@
           <p:cNvPr id="21" name="">
             <a:extLst xmlns:a="http://schemas.openxmlformats.org/drawingml/2006/main">
               <a:ext uri="{FF2B5EF4-FFF2-40B4-BE49-F238E27FC236}">
-                <a16:creationId xmlns:a16="http://schemas.microsoft.com/office/drawing/2014/main" id="{F48834DD-7B8D-4DE6-9F0A-4A4C5470548B}"/>
+                <a16:creationId xmlns:a16="http://schemas.microsoft.com/office/drawing/2014/main" id="{66D2DD5D-6E87-4895-A33D-A366C1911996}"/>
               </a:ext>
             </a:extLst>
           </p:cNvPr>
@@ -5863,7 +5858,7 @@
           <p:cNvPr id="22" name="">
             <a:extLst xmlns:a="http://schemas.openxmlformats.org/drawingml/2006/main">
               <a:ext uri="{FF2B5EF4-FFF2-40B4-BE49-F238E27FC236}">
-                <a16:creationId xmlns:a16="http://schemas.microsoft.com/office/drawing/2014/main" id="{7C2ED0AF-6EC2-4127-9F27-AA457F42655D}"/>
+                <a16:creationId xmlns:a16="http://schemas.microsoft.com/office/drawing/2014/main" id="{3F0B7E0A-A6DB-43CA-904F-5C656B17198F}"/>
               </a:ext>
             </a:extLst>
           </p:cNvPr>
@@ -5913,7 +5908,7 @@
           <p:cNvPr id="23" name="">
             <a:extLst xmlns:a="http://schemas.openxmlformats.org/drawingml/2006/main">
               <a:ext uri="{FF2B5EF4-FFF2-40B4-BE49-F238E27FC236}">
-                <a16:creationId xmlns:a16="http://schemas.microsoft.com/office/drawing/2014/main" id="{84D60711-1AD8-491C-A180-07D7A19B7475}"/>
+                <a16:creationId xmlns:a16="http://schemas.microsoft.com/office/drawing/2014/main" id="{43311140-B7C9-4BB5-A230-F6A09FF0F032}"/>
               </a:ext>
             </a:extLst>
           </p:cNvPr>
@@ -5946,7 +5941,7 @@
           <p:cNvPr id="24" name="">
             <a:extLst xmlns:a="http://schemas.openxmlformats.org/drawingml/2006/main">
               <a:ext uri="{FF2B5EF4-FFF2-40B4-BE49-F238E27FC236}">
-                <a16:creationId xmlns:a16="http://schemas.microsoft.com/office/drawing/2014/main" id="{BC520C1C-4488-419B-A3FE-AF877701A4D0}"/>
+                <a16:creationId xmlns:a16="http://schemas.microsoft.com/office/drawing/2014/main" id="{D64D790D-2DC5-4D64-9FEA-830A53F5E077}"/>
               </a:ext>
             </a:extLst>
           </p:cNvPr>
@@ -5958,7 +5953,7 @@
         <p:spPr>
           <a:xfrm xmlns:a="http://schemas.openxmlformats.org/drawingml/2006/main">
             <a:off x="7353300" y="5191125"/>
-            <a:ext cx="704850" cy="228600"/>
+            <a:ext cx="952500" cy="228600"/>
           </a:xfrm>
           <a:prstGeom xmlns:a="http://schemas.openxmlformats.org/drawingml/2006/main" prst="rect">
             <a:avLst/>
@@ -5986,7 +5981,7 @@
                   <a:srgbClr val="B7791F"/>
                 </a:solidFill>
               </a:rPr>
-              <a:t>Bound</a:t>
+              <a:t>Observed</a:t>
             </a:r>
           </a:p>
         </p:txBody>
@@ -5996,19 +5991,19 @@
           <p:cNvPr id="25" name="">
             <a:extLst xmlns:a="http://schemas.openxmlformats.org/drawingml/2006/main">
               <a:ext uri="{FF2B5EF4-FFF2-40B4-BE49-F238E27FC236}">
-                <a16:creationId xmlns:a16="http://schemas.microsoft.com/office/drawing/2014/main" id="{A2BAB13F-B84B-465C-9BF1-19A84293481B}"/>
-              </a:ext>
-            </a:extLst>
-          </p:cNvPr>
-          <p:cNvSpPr>
-            <a:spLocks xmlns:a="http://schemas.openxmlformats.org/drawingml/2006/main" noGrp="1"/>
-          </p:cNvSpPr>
-          <p:nvPr/>
-        </p:nvSpPr>
-        <p:spPr>
-          <a:xfrm xmlns:a="http://schemas.openxmlformats.org/drawingml/2006/main">
-            <a:off x="8115300" y="5124450"/>
-            <a:ext cx="2705100" cy="419100"/>
+                <a16:creationId xmlns:a16="http://schemas.microsoft.com/office/drawing/2014/main" id="{D476802A-1CC0-4192-B70B-E19A30DB4674}"/>
+              </a:ext>
+            </a:extLst>
+          </p:cNvPr>
+          <p:cNvSpPr>
+            <a:spLocks xmlns:a="http://schemas.openxmlformats.org/drawingml/2006/main" noGrp="1"/>
+          </p:cNvSpPr>
+          <p:nvPr/>
+        </p:nvSpPr>
+        <p:spPr>
+          <a:xfrm xmlns:a="http://schemas.openxmlformats.org/drawingml/2006/main">
+            <a:off x="8420100" y="5124450"/>
+            <a:ext cx="2400300" cy="419100"/>
           </a:xfrm>
           <a:prstGeom xmlns:a="http://schemas.openxmlformats.org/drawingml/2006/main" prst="rect">
             <a:avLst/>
@@ -6036,7 +6031,7 @@
                   <a:srgbClr val="243B53"/>
                 </a:solidFill>
               </a:rPr>
-              <a:t>At most one targeted generation cycle before suite freeze.</a:t>
+              <a:t>0 targeted cycles · minimum coverage already satisfied.</a:t>
             </a:r>
           </a:p>
         </p:txBody>
@@ -6044,7 +6039,7 @@
     </p:spTree>
     <p:extLst>
       <p:ext uri="{BB962C8B-B14F-4D97-AF65-F5344CB8AC3E}">
-        <p14:creationId xmlns:p14="http://schemas.microsoft.com/office/powerpoint/2010/main" val="495855401"/>
+        <p14:creationId xmlns:p14="http://schemas.microsoft.com/office/powerpoint/2010/main" val="1630520510"/>
       </p:ext>
     </p:extLst>
   </p:cSld>
@@ -6075,7 +6070,7 @@
           <p:cNvPr id="22" name="">
             <a:extLst xmlns:a="http://schemas.openxmlformats.org/drawingml/2006/main">
               <a:ext uri="{FF2B5EF4-FFF2-40B4-BE49-F238E27FC236}">
-                <a16:creationId xmlns:a16="http://schemas.microsoft.com/office/drawing/2014/main" id="{5689E6C4-B500-4CB5-9936-411EC19E326F}"/>
+                <a16:creationId xmlns:a16="http://schemas.microsoft.com/office/drawing/2014/main" id="{EEF490EB-63AB-45E9-BED1-9873607A8517}"/>
               </a:ext>
             </a:extLst>
           </p:cNvPr>
@@ -6106,7 +6101,7 @@
           <p:cNvPr id="2" name="">
             <a:extLst xmlns:a="http://schemas.openxmlformats.org/drawingml/2006/main">
               <a:ext uri="{FF2B5EF4-FFF2-40B4-BE49-F238E27FC236}">
-                <a16:creationId xmlns:a16="http://schemas.microsoft.com/office/drawing/2014/main" id="{D61A7208-8DE7-49E4-8847-E800803A8980}"/>
+                <a16:creationId xmlns:a16="http://schemas.microsoft.com/office/drawing/2014/main" id="{8AFC4590-8A59-4280-B32A-73C6F50E4BB5}"/>
               </a:ext>
             </a:extLst>
           </p:cNvPr>
@@ -6146,7 +6141,7 @@
                   <a:srgbClr val="0F766E"/>
                 </a:solidFill>
               </a:rPr>
-              <a:t>TARGET ARCHITECTURE · INTEGRATION PENDING</a:t>
+              <a:t>CURRENT ARCHITECTURE · CACHED REHEARSAL</a:t>
             </a:r>
           </a:p>
         </p:txBody>
@@ -6156,7 +6151,7 @@
           <p:cNvPr id="3" name="">
             <a:extLst xmlns:a="http://schemas.openxmlformats.org/drawingml/2006/main">
               <a:ext uri="{FF2B5EF4-FFF2-40B4-BE49-F238E27FC236}">
-                <a16:creationId xmlns:a16="http://schemas.microsoft.com/office/drawing/2014/main" id="{4B645468-90FA-4760-9D9B-847BD37D14F9}"/>
+                <a16:creationId xmlns:a16="http://schemas.microsoft.com/office/drawing/2014/main" id="{48AA8D18-3098-48A3-A69D-92D65899C1EB}"/>
               </a:ext>
             </a:extLst>
           </p:cNvPr>
@@ -6206,7 +6201,7 @@
           <p:cNvPr id="4" name="">
             <a:extLst xmlns:a="http://schemas.openxmlformats.org/drawingml/2006/main">
               <a:ext uri="{FF2B5EF4-FFF2-40B4-BE49-F238E27FC236}">
-                <a16:creationId xmlns:a16="http://schemas.microsoft.com/office/drawing/2014/main" id="{445193D7-D0D5-4B73-963F-92367DD1662A}"/>
+                <a16:creationId xmlns:a16="http://schemas.microsoft.com/office/drawing/2014/main" id="{F405F0C5-B96F-4C28-9849-719B88456C5E}"/>
               </a:ext>
             </a:extLst>
           </p:cNvPr>
@@ -6237,7 +6232,7 @@
           <p:cNvPr id="5" name="">
             <a:extLst xmlns:a="http://schemas.openxmlformats.org/drawingml/2006/main">
               <a:ext uri="{FF2B5EF4-FFF2-40B4-BE49-F238E27FC236}">
-                <a16:creationId xmlns:a16="http://schemas.microsoft.com/office/drawing/2014/main" id="{B8B4C2E9-4158-4C75-A3CA-DD2FB89C6230}"/>
+                <a16:creationId xmlns:a16="http://schemas.microsoft.com/office/drawing/2014/main" id="{D5E1B8E4-D6E0-4931-B415-107D7C01D07A}"/>
               </a:ext>
             </a:extLst>
           </p:cNvPr>
@@ -6287,7 +6282,7 @@
           <p:cNvPr id="6" name="">
             <a:extLst xmlns:a="http://schemas.openxmlformats.org/drawingml/2006/main">
               <a:ext uri="{FF2B5EF4-FFF2-40B4-BE49-F238E27FC236}">
-                <a16:creationId xmlns:a16="http://schemas.microsoft.com/office/drawing/2014/main" id="{6450A096-DAB4-4E24-A627-B60325969A1A}"/>
+                <a16:creationId xmlns:a16="http://schemas.microsoft.com/office/drawing/2014/main" id="{FEADA267-6400-4CB3-BF4E-60A1924733C7}"/>
               </a:ext>
             </a:extLst>
           </p:cNvPr>
@@ -6337,7 +6332,7 @@
           <p:cNvPr id="7" name="">
             <a:extLst xmlns:a="http://schemas.openxmlformats.org/drawingml/2006/main">
               <a:ext uri="{FF2B5EF4-FFF2-40B4-BE49-F238E27FC236}">
-                <a16:creationId xmlns:a16="http://schemas.microsoft.com/office/drawing/2014/main" id="{270154D8-7052-474A-99D8-4B082A38A8D9}"/>
+                <a16:creationId xmlns:a16="http://schemas.microsoft.com/office/drawing/2014/main" id="{EC4581EF-E4AF-4C58-B01F-B5CAF2D075D9}"/>
               </a:ext>
             </a:extLst>
           </p:cNvPr>
@@ -6368,7 +6363,7 @@
           <p:cNvPr id="8" name="">
             <a:extLst xmlns:a="http://schemas.openxmlformats.org/drawingml/2006/main">
               <a:ext uri="{FF2B5EF4-FFF2-40B4-BE49-F238E27FC236}">
-                <a16:creationId xmlns:a16="http://schemas.microsoft.com/office/drawing/2014/main" id="{68717EB4-ACE4-479F-9438-2BBECD428194}"/>
+                <a16:creationId xmlns:a16="http://schemas.microsoft.com/office/drawing/2014/main" id="{07EDA7A6-901F-4667-A2C5-9162EE9186E9}"/>
               </a:ext>
             </a:extLst>
           </p:cNvPr>
@@ -6399,7 +6394,7 @@
           <p:cNvPr id="9" name="">
             <a:extLst xmlns:a="http://schemas.openxmlformats.org/drawingml/2006/main">
               <a:ext uri="{FF2B5EF4-FFF2-40B4-BE49-F238E27FC236}">
-                <a16:creationId xmlns:a16="http://schemas.microsoft.com/office/drawing/2014/main" id="{3710BB96-B9C5-4BAA-B925-973D550010C5}"/>
+                <a16:creationId xmlns:a16="http://schemas.microsoft.com/office/drawing/2014/main" id="{6E19FC36-3B30-492B-868C-BE80F0CA6696}"/>
               </a:ext>
             </a:extLst>
           </p:cNvPr>
@@ -6430,7 +6425,7 @@
           <p:cNvPr id="10" name="">
             <a:extLst xmlns:a="http://schemas.openxmlformats.org/drawingml/2006/main">
               <a:ext uri="{FF2B5EF4-FFF2-40B4-BE49-F238E27FC236}">
-                <a16:creationId xmlns:a16="http://schemas.microsoft.com/office/drawing/2014/main" id="{7D028691-C84D-4AA2-AD19-99950739D861}"/>
+                <a16:creationId xmlns:a16="http://schemas.microsoft.com/office/drawing/2014/main" id="{4316AB68-12A8-4CCB-9562-1199F80B23F8}"/>
               </a:ext>
             </a:extLst>
           </p:cNvPr>
@@ -6497,7 +6492,7 @@
           <p:cNvPr id="11" name="">
             <a:extLst xmlns:a="http://schemas.openxmlformats.org/drawingml/2006/main">
               <a:ext uri="{FF2B5EF4-FFF2-40B4-BE49-F238E27FC236}">
-                <a16:creationId xmlns:a16="http://schemas.microsoft.com/office/drawing/2014/main" id="{BB3F3600-71D3-4ED4-99C5-5688A3BBC5D5}"/>
+                <a16:creationId xmlns:a16="http://schemas.microsoft.com/office/drawing/2014/main" id="{A5AFB505-D2E4-449C-9829-025A71D6DC10}"/>
               </a:ext>
             </a:extLst>
           </p:cNvPr>
@@ -6532,7 +6527,7 @@
           <p:cNvPr id="12" name="">
             <a:extLst xmlns:a="http://schemas.openxmlformats.org/drawingml/2006/main">
               <a:ext uri="{FF2B5EF4-FFF2-40B4-BE49-F238E27FC236}">
-                <a16:creationId xmlns:a16="http://schemas.microsoft.com/office/drawing/2014/main" id="{F7C634E7-52E2-4B3F-8034-15DE243AAD0F}"/>
+                <a16:creationId xmlns:a16="http://schemas.microsoft.com/office/drawing/2014/main" id="{7E0686D6-8C22-4065-BB19-D84E844D3853}"/>
               </a:ext>
             </a:extLst>
           </p:cNvPr>
@@ -6582,7 +6577,7 @@
           <p:cNvPr id="13" name="">
             <a:extLst xmlns:a="http://schemas.openxmlformats.org/drawingml/2006/main">
               <a:ext uri="{FF2B5EF4-FFF2-40B4-BE49-F238E27FC236}">
-                <a16:creationId xmlns:a16="http://schemas.microsoft.com/office/drawing/2014/main" id="{8B0C5514-7C86-46C8-8070-2932E7902D61}"/>
+                <a16:creationId xmlns:a16="http://schemas.microsoft.com/office/drawing/2014/main" id="{53A6AC28-6C49-434E-84FB-AE3C2804AB78}"/>
               </a:ext>
             </a:extLst>
           </p:cNvPr>
@@ -6636,7 +6631,7 @@
           <p:cNvPr id="14" name="">
             <a:extLst xmlns:a="http://schemas.openxmlformats.org/drawingml/2006/main">
               <a:ext uri="{FF2B5EF4-FFF2-40B4-BE49-F238E27FC236}">
-                <a16:creationId xmlns:a16="http://schemas.microsoft.com/office/drawing/2014/main" id="{EAC9BBB7-0B99-4BAB-8D09-38100C249CB4}"/>
+                <a16:creationId xmlns:a16="http://schemas.microsoft.com/office/drawing/2014/main" id="{64D3F367-8BEA-48AA-A3B1-0C327BC265B4}"/>
               </a:ext>
             </a:extLst>
           </p:cNvPr>
@@ -6737,7 +6732,7 @@
           <p:cNvPr id="15" name="">
             <a:extLst xmlns:a="http://schemas.openxmlformats.org/drawingml/2006/main">
               <a:ext uri="{FF2B5EF4-FFF2-40B4-BE49-F238E27FC236}">
-                <a16:creationId xmlns:a16="http://schemas.microsoft.com/office/drawing/2014/main" id="{C833EFF3-4AEA-4212-8530-0561B4637FDC}"/>
+                <a16:creationId xmlns:a16="http://schemas.microsoft.com/office/drawing/2014/main" id="{E4A9F6BB-D089-4593-869D-7F71CFC824E3}"/>
               </a:ext>
             </a:extLst>
           </p:cNvPr>
@@ -6770,7 +6765,7 @@
           <p:cNvPr id="16" name="">
             <a:extLst xmlns:a="http://schemas.openxmlformats.org/drawingml/2006/main">
               <a:ext uri="{FF2B5EF4-FFF2-40B4-BE49-F238E27FC236}">
-                <a16:creationId xmlns:a16="http://schemas.microsoft.com/office/drawing/2014/main" id="{13824204-CAC5-4ADF-93D9-3BD716CABD8B}"/>
+                <a16:creationId xmlns:a16="http://schemas.microsoft.com/office/drawing/2014/main" id="{D55D4A98-2B49-4552-9053-FAA37F58E2C4}"/>
               </a:ext>
             </a:extLst>
           </p:cNvPr>
@@ -6820,7 +6815,7 @@
           <p:cNvPr id="17" name="">
             <a:extLst xmlns:a="http://schemas.openxmlformats.org/drawingml/2006/main">
               <a:ext uri="{FF2B5EF4-FFF2-40B4-BE49-F238E27FC236}">
-                <a16:creationId xmlns:a16="http://schemas.microsoft.com/office/drawing/2014/main" id="{C7AC5467-C870-4762-823F-1FAE34007162}"/>
+                <a16:creationId xmlns:a16="http://schemas.microsoft.com/office/drawing/2014/main" id="{7EBB54E3-DEE6-43AE-B9F7-0FB859902E57}"/>
               </a:ext>
             </a:extLst>
           </p:cNvPr>
@@ -6904,7 +6899,7 @@
           <p:cNvPr id="18" name="">
             <a:extLst xmlns:a="http://schemas.openxmlformats.org/drawingml/2006/main">
               <a:ext uri="{FF2B5EF4-FFF2-40B4-BE49-F238E27FC236}">
-                <a16:creationId xmlns:a16="http://schemas.microsoft.com/office/drawing/2014/main" id="{F538051D-6026-418F-B35E-1D9DE7D3267A}"/>
+                <a16:creationId xmlns:a16="http://schemas.microsoft.com/office/drawing/2014/main" id="{FBC36612-6C56-43D4-98C6-E9A16450506E}"/>
               </a:ext>
             </a:extLst>
           </p:cNvPr>
@@ -6937,7 +6932,7 @@
           <p:cNvPr id="19" name="">
             <a:extLst xmlns:a="http://schemas.openxmlformats.org/drawingml/2006/main">
               <a:ext uri="{FF2B5EF4-FFF2-40B4-BE49-F238E27FC236}">
-                <a16:creationId xmlns:a16="http://schemas.microsoft.com/office/drawing/2014/main" id="{EFC2189D-E821-4E26-99DD-B1DC8D4137FC}"/>
+                <a16:creationId xmlns:a16="http://schemas.microsoft.com/office/drawing/2014/main" id="{F37671AE-CCF7-4DD0-A314-75CFB6B73B99}"/>
               </a:ext>
             </a:extLst>
           </p:cNvPr>
@@ -6987,7 +6982,7 @@
           <p:cNvPr id="20" name="">
             <a:extLst xmlns:a="http://schemas.openxmlformats.org/drawingml/2006/main">
               <a:ext uri="{FF2B5EF4-FFF2-40B4-BE49-F238E27FC236}">
-                <a16:creationId xmlns:a16="http://schemas.microsoft.com/office/drawing/2014/main" id="{36F218B3-C31B-41F3-A24D-84E4254F3721}"/>
+                <a16:creationId xmlns:a16="http://schemas.microsoft.com/office/drawing/2014/main" id="{6D179432-A939-4C26-8651-AB6C46F73CC9}"/>
               </a:ext>
             </a:extLst>
           </p:cNvPr>
@@ -7041,7 +7036,7 @@
           <p:cNvPr id="21" name="">
             <a:extLst xmlns:a="http://schemas.openxmlformats.org/drawingml/2006/main">
               <a:ext uri="{FF2B5EF4-FFF2-40B4-BE49-F238E27FC236}">
-                <a16:creationId xmlns:a16="http://schemas.microsoft.com/office/drawing/2014/main" id="{A5289A0E-749B-49BB-9A2C-B9867648B789}"/>
+                <a16:creationId xmlns:a16="http://schemas.microsoft.com/office/drawing/2014/main" id="{463EFA82-38F9-4992-B89F-0CDC00E53E84}"/>
               </a:ext>
             </a:extLst>
           </p:cNvPr>
@@ -7157,7 +7152,7 @@
     </p:spTree>
     <p:extLst>
       <p:ext uri="{BB962C8B-B14F-4D97-AF65-F5344CB8AC3E}">
-        <p14:creationId xmlns:p14="http://schemas.microsoft.com/office/powerpoint/2010/main" val="112626260"/>
+        <p14:creationId xmlns:p14="http://schemas.microsoft.com/office/powerpoint/2010/main" val="2074646783"/>
       </p:ext>
     </p:extLst>
   </p:cSld>
@@ -7188,7 +7183,7 @@
           <p:cNvPr id="30" name="">
             <a:extLst xmlns:a="http://schemas.openxmlformats.org/drawingml/2006/main">
               <a:ext uri="{FF2B5EF4-FFF2-40B4-BE49-F238E27FC236}">
-                <a16:creationId xmlns:a16="http://schemas.microsoft.com/office/drawing/2014/main" id="{97CD8576-C5AB-4390-B5D2-895164E362EE}"/>
+                <a16:creationId xmlns:a16="http://schemas.microsoft.com/office/drawing/2014/main" id="{409AD7E9-E8C8-48DD-B755-8358174996DC}"/>
               </a:ext>
             </a:extLst>
           </p:cNvPr>
@@ -7219,7 +7214,7 @@
           <p:cNvPr id="2" name="">
             <a:extLst xmlns:a="http://schemas.openxmlformats.org/drawingml/2006/main">
               <a:ext uri="{FF2B5EF4-FFF2-40B4-BE49-F238E27FC236}">
-                <a16:creationId xmlns:a16="http://schemas.microsoft.com/office/drawing/2014/main" id="{F67ABCFA-DA3F-478A-A5AB-2A92983EE7EF}"/>
+                <a16:creationId xmlns:a16="http://schemas.microsoft.com/office/drawing/2014/main" id="{6671B212-48E2-4F63-9B9A-700B9CA1B2B4}"/>
               </a:ext>
             </a:extLst>
           </p:cNvPr>
@@ -7259,7 +7254,7 @@
                   <a:srgbClr val="0F766E"/>
                 </a:solidFill>
               </a:rPr>
-              <a:t>PLANNED DEVELOPMENT CASES · SYNTHETIC</a:t>
+              <a:t>CURRENT CACHED FINDINGS · SYNTHETIC REHEARSAL</a:t>
             </a:r>
           </a:p>
         </p:txBody>
@@ -7269,7 +7264,7 @@
           <p:cNvPr id="3" name="">
             <a:extLst xmlns:a="http://schemas.openxmlformats.org/drawingml/2006/main">
               <a:ext uri="{FF2B5EF4-FFF2-40B4-BE49-F238E27FC236}">
-                <a16:creationId xmlns:a16="http://schemas.microsoft.com/office/drawing/2014/main" id="{FE3BC4A8-7337-415D-8232-7588D6B7C688}"/>
+                <a16:creationId xmlns:a16="http://schemas.microsoft.com/office/drawing/2014/main" id="{DEFBE2DE-AAB2-4551-8657-3C7F4B4095E8}"/>
               </a:ext>
             </a:extLst>
           </p:cNvPr>
@@ -7319,7 +7314,7 @@
           <p:cNvPr id="4" name="">
             <a:extLst xmlns:a="http://schemas.openxmlformats.org/drawingml/2006/main">
               <a:ext uri="{FF2B5EF4-FFF2-40B4-BE49-F238E27FC236}">
-                <a16:creationId xmlns:a16="http://schemas.microsoft.com/office/drawing/2014/main" id="{67E55A9E-F7D2-4CB8-B9F7-FE7A9BD7766F}"/>
+                <a16:creationId xmlns:a16="http://schemas.microsoft.com/office/drawing/2014/main" id="{5F459209-7471-4CC1-99E8-8CCA54801796}"/>
               </a:ext>
             </a:extLst>
           </p:cNvPr>
@@ -7350,7 +7345,7 @@
           <p:cNvPr id="5" name="">
             <a:extLst xmlns:a="http://schemas.openxmlformats.org/drawingml/2006/main">
               <a:ext uri="{FF2B5EF4-FFF2-40B4-BE49-F238E27FC236}">
-                <a16:creationId xmlns:a16="http://schemas.microsoft.com/office/drawing/2014/main" id="{C71BB27F-979F-4839-B3D6-16C8F1EE236D}"/>
+                <a16:creationId xmlns:a16="http://schemas.microsoft.com/office/drawing/2014/main" id="{F6EB4ECE-498A-4334-BE73-5FD19E0089EA}"/>
               </a:ext>
             </a:extLst>
           </p:cNvPr>
@@ -7400,7 +7395,7 @@
           <p:cNvPr id="6" name="">
             <a:extLst xmlns:a="http://schemas.openxmlformats.org/drawingml/2006/main">
               <a:ext uri="{FF2B5EF4-FFF2-40B4-BE49-F238E27FC236}">
-                <a16:creationId xmlns:a16="http://schemas.microsoft.com/office/drawing/2014/main" id="{8B2879FB-7BC1-4144-A14B-1031156935CD}"/>
+                <a16:creationId xmlns:a16="http://schemas.microsoft.com/office/drawing/2014/main" id="{1019A878-4666-4963-8003-12FA6406FE1F}"/>
               </a:ext>
             </a:extLst>
           </p:cNvPr>
@@ -7440,7 +7435,7 @@
                   <a:srgbClr val="102A43"/>
                 </a:solidFill>
               </a:rPr>
-              <a:t>Three planned cases make ambiguity executable</a:t>
+              <a:t>Three deterministic findings make ambiguity executable</a:t>
             </a:r>
           </a:p>
         </p:txBody>
@@ -7450,7 +7445,7 @@
           <p:cNvPr id="7" name="">
             <a:extLst xmlns:a="http://schemas.openxmlformats.org/drawingml/2006/main">
               <a:ext uri="{FF2B5EF4-FFF2-40B4-BE49-F238E27FC236}">
-                <a16:creationId xmlns:a16="http://schemas.microsoft.com/office/drawing/2014/main" id="{C6F37AC8-E3D1-49BF-88D1-D65F0B749A61}"/>
+                <a16:creationId xmlns:a16="http://schemas.microsoft.com/office/drawing/2014/main" id="{F087F4FF-3233-4FF2-A1DF-CB0AECC8FE82}"/>
               </a:ext>
             </a:extLst>
           </p:cNvPr>
@@ -7481,7 +7476,7 @@
           <p:cNvPr id="8" name="">
             <a:extLst xmlns:a="http://schemas.openxmlformats.org/drawingml/2006/main">
               <a:ext uri="{FF2B5EF4-FFF2-40B4-BE49-F238E27FC236}">
-                <a16:creationId xmlns:a16="http://schemas.microsoft.com/office/drawing/2014/main" id="{1CE99137-656B-427F-9B06-1415134B17DF}"/>
+                <a16:creationId xmlns:a16="http://schemas.microsoft.com/office/drawing/2014/main" id="{4584D311-DDD2-442E-AD11-BD4B2A29C0D9}"/>
               </a:ext>
             </a:extLst>
           </p:cNvPr>
@@ -7531,7 +7526,7 @@
           <p:cNvPr id="9" name="">
             <a:extLst xmlns:a="http://schemas.openxmlformats.org/drawingml/2006/main">
               <a:ext uri="{FF2B5EF4-FFF2-40B4-BE49-F238E27FC236}">
-                <a16:creationId xmlns:a16="http://schemas.microsoft.com/office/drawing/2014/main" id="{6727E2A4-D291-4AC6-8D09-28A50D3CCF77}"/>
+                <a16:creationId xmlns:a16="http://schemas.microsoft.com/office/drawing/2014/main" id="{9C12B703-95FB-477C-9186-CC67A3FE4585}"/>
               </a:ext>
             </a:extLst>
           </p:cNvPr>
@@ -7571,7 +7566,7 @@
                   <a:srgbClr val="102A43"/>
                 </a:solidFill>
               </a:rPr>
-              <a:t>THRESHOLD GAP</a:t>
+              <a:t>RECEIPT REQUIREMENT</a:t>
             </a:r>
           </a:p>
         </p:txBody>
@@ -7581,7 +7576,7 @@
           <p:cNvPr id="10" name="">
             <a:extLst xmlns:a="http://schemas.openxmlformats.org/drawingml/2006/main">
               <a:ext uri="{FF2B5EF4-FFF2-40B4-BE49-F238E27FC236}">
-                <a16:creationId xmlns:a16="http://schemas.microsoft.com/office/drawing/2014/main" id="{DFD1AAC6-3854-49AF-9A0E-947D2D62ACEA}"/>
+                <a16:creationId xmlns:a16="http://schemas.microsoft.com/office/drawing/2014/main" id="{262BEC3D-06C3-46D3-AAB0-4CF298C49880}"/>
               </a:ext>
             </a:extLst>
           </p:cNvPr>
@@ -7621,7 +7616,7 @@
                   <a:srgbClr val="627D8C"/>
                 </a:solidFill>
               </a:rPr>
-              <a:t>SGD 50.00 receipt claim</a:t>
+              <a:t>Deterministic baseline finding</a:t>
             </a:r>
           </a:p>
         </p:txBody>
@@ -7631,7 +7626,7 @@
           <p:cNvPr id="11" name="">
             <a:extLst xmlns:a="http://schemas.openxmlformats.org/drawingml/2006/main">
               <a:ext uri="{FF2B5EF4-FFF2-40B4-BE49-F238E27FC236}">
-                <a16:creationId xmlns:a16="http://schemas.microsoft.com/office/drawing/2014/main" id="{7EEB73A6-23C2-4E6C-BE52-4AFD260CF163}"/>
+                <a16:creationId xmlns:a16="http://schemas.microsoft.com/office/drawing/2014/main" id="{50D03BA4-844C-47F4-9D8F-4F2DB40C31EC}"/>
               </a:ext>
             </a:extLst>
           </p:cNvPr>
@@ -7671,7 +7666,7 @@
                   <a:srgbClr val="B74D4D"/>
                 </a:solidFill>
               </a:rPr>
-              <a:t>below 50 ≠ above 50</a:t>
+              <a:t>Visible witness + cited rules</a:t>
             </a:r>
           </a:p>
         </p:txBody>
@@ -7681,7 +7676,7 @@
           <p:cNvPr id="12" name="">
             <a:extLst xmlns:a="http://schemas.openxmlformats.org/drawingml/2006/main">
               <a:ext uri="{FF2B5EF4-FFF2-40B4-BE49-F238E27FC236}">
-                <a16:creationId xmlns:a16="http://schemas.microsoft.com/office/drawing/2014/main" id="{9E052C31-7502-48CA-B86F-917B281F63A5}"/>
+                <a16:creationId xmlns:a16="http://schemas.microsoft.com/office/drawing/2014/main" id="{A1FA5F9D-2FCD-490F-976B-DD709E657CC6}"/>
               </a:ext>
             </a:extLst>
           </p:cNvPr>
@@ -7721,7 +7716,7 @@
                   <a:srgbClr val="627D8C"/>
                 </a:solidFill>
               </a:rPr>
-              <a:t>Equality has no matching rule</a:t>
+              <a:t>Accepted by authored demo decision</a:t>
             </a:r>
           </a:p>
         </p:txBody>
@@ -7731,7 +7726,7 @@
           <p:cNvPr id="13" name="">
             <a:extLst xmlns:a="http://schemas.openxmlformats.org/drawingml/2006/main">
               <a:ext uri="{FF2B5EF4-FFF2-40B4-BE49-F238E27FC236}">
-                <a16:creationId xmlns:a16="http://schemas.microsoft.com/office/drawing/2014/main" id="{682B664E-0F05-4855-A623-B25403F9C218}"/>
+                <a16:creationId xmlns:a16="http://schemas.microsoft.com/office/drawing/2014/main" id="{0DACAC57-CA71-49D0-8F9E-CBE12809D0F8}"/>
               </a:ext>
             </a:extLst>
           </p:cNvPr>
@@ -7775,7 +7770,7 @@
                   <a:srgbClr val="B7791F"/>
                 </a:solidFill>
               </a:rPr>
-              <a:t>TRACE + CITATION PENDING</a:t>
+              <a:t>FROZEN CAPTURE PENDING</a:t>
             </a:r>
           </a:p>
         </p:txBody>
@@ -7785,7 +7780,7 @@
           <p:cNvPr id="14" name="">
             <a:extLst xmlns:a="http://schemas.openxmlformats.org/drawingml/2006/main">
               <a:ext uri="{FF2B5EF4-FFF2-40B4-BE49-F238E27FC236}">
-                <a16:creationId xmlns:a16="http://schemas.microsoft.com/office/drawing/2014/main" id="{7E8FAF51-1432-4191-87F3-1B2E2B470949}"/>
+                <a16:creationId xmlns:a16="http://schemas.microsoft.com/office/drawing/2014/main" id="{A4DC0F55-B6E2-484E-9824-7D1B5C5140EA}"/>
               </a:ext>
             </a:extLst>
           </p:cNvPr>
@@ -7816,7 +7811,7 @@
           <p:cNvPr id="15" name="">
             <a:extLst xmlns:a="http://schemas.openxmlformats.org/drawingml/2006/main">
               <a:ext uri="{FF2B5EF4-FFF2-40B4-BE49-F238E27FC236}">
-                <a16:creationId xmlns:a16="http://schemas.microsoft.com/office/drawing/2014/main" id="{30F57C69-34C1-4E2E-9D3E-0FF7525BB591}"/>
+                <a16:creationId xmlns:a16="http://schemas.microsoft.com/office/drawing/2014/main" id="{009E27A4-A296-4790-B68B-C891E3A0BBC2}"/>
               </a:ext>
             </a:extLst>
           </p:cNvPr>
@@ -7866,7 +7861,7 @@
           <p:cNvPr id="16" name="">
             <a:extLst xmlns:a="http://schemas.openxmlformats.org/drawingml/2006/main">
               <a:ext uri="{FF2B5EF4-FFF2-40B4-BE49-F238E27FC236}">
-                <a16:creationId xmlns:a16="http://schemas.microsoft.com/office/drawing/2014/main" id="{71B1F6CB-D189-4B9F-867B-8B635F426EA4}"/>
+                <a16:creationId xmlns:a16="http://schemas.microsoft.com/office/drawing/2014/main" id="{6568EF74-774C-457E-917D-90784852A75A}"/>
               </a:ext>
             </a:extLst>
           </p:cNvPr>
@@ -7906,7 +7901,7 @@
                   <a:srgbClr val="102A43"/>
                 </a:solidFill>
               </a:rPr>
-              <a:t>HOTEL CONFLICT</a:t>
+              <a:t>APPROVAL REQUIREMENT</a:t>
             </a:r>
           </a:p>
         </p:txBody>
@@ -7916,7 +7911,7 @@
           <p:cNvPr id="17" name="">
             <a:extLst xmlns:a="http://schemas.openxmlformats.org/drawingml/2006/main">
               <a:ext uri="{FF2B5EF4-FFF2-40B4-BE49-F238E27FC236}">
-                <a16:creationId xmlns:a16="http://schemas.microsoft.com/office/drawing/2014/main" id="{BC69DC48-5005-4948-975D-797894D47A61}"/>
+                <a16:creationId xmlns:a16="http://schemas.microsoft.com/office/drawing/2014/main" id="{40F7CD43-592A-4C02-BFC5-CF4ABBF205F2}"/>
               </a:ext>
             </a:extLst>
           </p:cNvPr>
@@ -7956,7 +7951,7 @@
                   <a:srgbClr val="627D8C"/>
                 </a:solidFill>
               </a:rPr>
-              <a:t>International hotel · SGD 249.00</a:t>
+              <a:t>Deterministic baseline finding</a:t>
             </a:r>
           </a:p>
         </p:txBody>
@@ -7966,7 +7961,7 @@
           <p:cNvPr id="18" name="">
             <a:extLst xmlns:a="http://schemas.openxmlformats.org/drawingml/2006/main">
               <a:ext uri="{FF2B5EF4-FFF2-40B4-BE49-F238E27FC236}">
-                <a16:creationId xmlns:a16="http://schemas.microsoft.com/office/drawing/2014/main" id="{82CB6E75-4EE7-40E2-8F5E-5A47F171AE10}"/>
+                <a16:creationId xmlns:a16="http://schemas.microsoft.com/office/drawing/2014/main" id="{8BD35D09-D66B-4B10-8560-DFF49134C3E4}"/>
               </a:ext>
             </a:extLst>
           </p:cNvPr>
@@ -8006,7 +8001,7 @@
                   <a:srgbClr val="0F766E"/>
                 </a:solidFill>
               </a:rPr>
-              <a:t>no approval ↔ manager approval</a:t>
+              <a:t>Visible witness + cited rules</a:t>
             </a:r>
           </a:p>
         </p:txBody>
@@ -8016,7 +8011,7 @@
           <p:cNvPr id="19" name="">
             <a:extLst xmlns:a="http://schemas.openxmlformats.org/drawingml/2006/main">
               <a:ext uri="{FF2B5EF4-FFF2-40B4-BE49-F238E27FC236}">
-                <a16:creationId xmlns:a16="http://schemas.microsoft.com/office/drawing/2014/main" id="{F1583C03-D66C-4C17-9FCC-66EEDAB34EDC}"/>
+                <a16:creationId xmlns:a16="http://schemas.microsoft.com/office/drawing/2014/main" id="{2ADAAE61-07F4-42A0-B889-93FF7EBF42CE}"/>
               </a:ext>
             </a:extLst>
           </p:cNvPr>
@@ -8056,7 +8051,7 @@
                   <a:srgbClr val="627D8C"/>
                 </a:solidFill>
               </a:rPr>
-              <a:t>No override resolves the clash</a:t>
+              <a:t>Accepted by authored demo decision</a:t>
             </a:r>
           </a:p>
         </p:txBody>
@@ -8066,7 +8061,7 @@
           <p:cNvPr id="20" name="">
             <a:extLst xmlns:a="http://schemas.openxmlformats.org/drawingml/2006/main">
               <a:ext uri="{FF2B5EF4-FFF2-40B4-BE49-F238E27FC236}">
-                <a16:creationId xmlns:a16="http://schemas.microsoft.com/office/drawing/2014/main" id="{AD7ACD03-12B4-45F4-9FB5-A337B1F51CEF}"/>
+                <a16:creationId xmlns:a16="http://schemas.microsoft.com/office/drawing/2014/main" id="{1A83C2C4-B7D2-4AB4-A524-1DC54260F60B}"/>
               </a:ext>
             </a:extLst>
           </p:cNvPr>
@@ -8110,7 +8105,7 @@
                   <a:srgbClr val="B7791F"/>
                 </a:solidFill>
               </a:rPr>
-              <a:t>TRACE + CITATION PENDING</a:t>
+              <a:t>FROZEN CAPTURE PENDING</a:t>
             </a:r>
           </a:p>
         </p:txBody>
@@ -8120,7 +8115,7 @@
           <p:cNvPr id="21" name="">
             <a:extLst xmlns:a="http://schemas.openxmlformats.org/drawingml/2006/main">
               <a:ext uri="{FF2B5EF4-FFF2-40B4-BE49-F238E27FC236}">
-                <a16:creationId xmlns:a16="http://schemas.microsoft.com/office/drawing/2014/main" id="{EF67C0D3-8774-4B70-868B-EAA5FD4D5C8A}"/>
+                <a16:creationId xmlns:a16="http://schemas.microsoft.com/office/drawing/2014/main" id="{377B43CF-8B46-4EBC-8788-BCC4795507C9}"/>
               </a:ext>
             </a:extLst>
           </p:cNvPr>
@@ -8151,7 +8146,7 @@
           <p:cNvPr id="22" name="">
             <a:extLst xmlns:a="http://schemas.openxmlformats.org/drawingml/2006/main">
               <a:ext uri="{FF2B5EF4-FFF2-40B4-BE49-F238E27FC236}">
-                <a16:creationId xmlns:a16="http://schemas.microsoft.com/office/drawing/2014/main" id="{9ED0230B-E1CA-412A-A84E-F64EABD9DD7A}"/>
+                <a16:creationId xmlns:a16="http://schemas.microsoft.com/office/drawing/2014/main" id="{78CD7C5C-30A9-4C2D-A82D-435520E6A851}"/>
               </a:ext>
             </a:extLst>
           </p:cNvPr>
@@ -8201,7 +8196,7 @@
           <p:cNvPr id="23" name="">
             <a:extLst xmlns:a="http://schemas.openxmlformats.org/drawingml/2006/main">
               <a:ext uri="{FF2B5EF4-FFF2-40B4-BE49-F238E27FC236}">
-                <a16:creationId xmlns:a16="http://schemas.microsoft.com/office/drawing/2014/main" id="{30674CA9-0504-4A28-93CC-15EAAA5D1ACB}"/>
+                <a16:creationId xmlns:a16="http://schemas.microsoft.com/office/drawing/2014/main" id="{C803B438-9976-4A2A-A52A-3B92D6A14BA6}"/>
               </a:ext>
             </a:extLst>
           </p:cNvPr>
@@ -8241,7 +8236,7 @@
                   <a:srgbClr val="102A43"/>
                 </a:solidFill>
               </a:rPr>
-              <a:t>DAILY CAP BREACH</a:t>
+              <a:t>DAILY CATEGORY CAP</a:t>
             </a:r>
           </a:p>
         </p:txBody>
@@ -8251,7 +8246,7 @@
           <p:cNvPr id="24" name="">
             <a:extLst xmlns:a="http://schemas.openxmlformats.org/drawingml/2006/main">
               <a:ext uri="{FF2B5EF4-FFF2-40B4-BE49-F238E27FC236}">
-                <a16:creationId xmlns:a16="http://schemas.microsoft.com/office/drawing/2014/main" id="{B5FEEA49-A5A3-42FB-8E64-242DB67A42EC}"/>
+                <a16:creationId xmlns:a16="http://schemas.microsoft.com/office/drawing/2014/main" id="{F83D6ECD-B34D-4906-B25D-88D67216CFCE}"/>
               </a:ext>
             </a:extLst>
           </p:cNvPr>
@@ -8291,7 +8286,7 @@
                   <a:srgbClr val="627D8C"/>
                 </a:solidFill>
               </a:rPr>
-              <a:t>Meal SGD 60 + prior SGD 50</a:t>
+              <a:t>Deterministic baseline finding</a:t>
             </a:r>
           </a:p>
         </p:txBody>
@@ -8301,7 +8296,7 @@
           <p:cNvPr id="25" name="">
             <a:extLst xmlns:a="http://schemas.openxmlformats.org/drawingml/2006/main">
               <a:ext uri="{FF2B5EF4-FFF2-40B4-BE49-F238E27FC236}">
-                <a16:creationId xmlns:a16="http://schemas.microsoft.com/office/drawing/2014/main" id="{F5D4A483-5CAD-42F6-98C6-4E2E1153BDA2}"/>
+                <a16:creationId xmlns:a16="http://schemas.microsoft.com/office/drawing/2014/main" id="{94C3F1ED-88E5-4E30-A8DF-384A4312B74E}"/>
               </a:ext>
             </a:extLst>
           </p:cNvPr>
@@ -8341,7 +8336,7 @@
                   <a:srgbClr val="0F766E"/>
                 </a:solidFill>
               </a:rPr>
-              <a:t>eligible per claim → daily total 110</a:t>
+              <a:t>Visible witness + cited intent</a:t>
             </a:r>
           </a:p>
         </p:txBody>
@@ -8351,7 +8346,7 @@
           <p:cNvPr id="26" name="">
             <a:extLst xmlns:a="http://schemas.openxmlformats.org/drawingml/2006/main">
               <a:ext uri="{FF2B5EF4-FFF2-40B4-BE49-F238E27FC236}">
-                <a16:creationId xmlns:a16="http://schemas.microsoft.com/office/drawing/2014/main" id="{D1E2588E-6D77-40F9-84F5-33CFF17FAC6C}"/>
+                <a16:creationId xmlns:a16="http://schemas.microsoft.com/office/drawing/2014/main" id="{F7622E9B-2E44-4D8A-8231-53CD214A8E58}"/>
               </a:ext>
             </a:extLst>
           </p:cNvPr>
@@ -8391,7 +8386,7 @@
                   <a:srgbClr val="627D8C"/>
                 </a:solidFill>
               </a:rPr>
-              <a:t>Confirmed daily intent is breached</a:t>
+              <a:t>Accepted by authored demo decision</a:t>
             </a:r>
           </a:p>
         </p:txBody>
@@ -8401,7 +8396,7 @@
           <p:cNvPr id="27" name="">
             <a:extLst xmlns:a="http://schemas.openxmlformats.org/drawingml/2006/main">
               <a:ext uri="{FF2B5EF4-FFF2-40B4-BE49-F238E27FC236}">
-                <a16:creationId xmlns:a16="http://schemas.microsoft.com/office/drawing/2014/main" id="{81A6C0CE-D59C-43CF-A4D7-09348DE61703}"/>
+                <a16:creationId xmlns:a16="http://schemas.microsoft.com/office/drawing/2014/main" id="{74CF633F-C68A-463F-8EA4-5B00DC322E60}"/>
               </a:ext>
             </a:extLst>
           </p:cNvPr>
@@ -8445,7 +8440,7 @@
                   <a:srgbClr val="B7791F"/>
                 </a:solidFill>
               </a:rPr>
-              <a:t>TRACE + CITATION PENDING</a:t>
+              <a:t>FROZEN CAPTURE PENDING</a:t>
             </a:r>
           </a:p>
         </p:txBody>
@@ -8455,7 +8450,7 @@
           <p:cNvPr id="28" name="">
             <a:extLst xmlns:a="http://schemas.openxmlformats.org/drawingml/2006/main">
               <a:ext uri="{FF2B5EF4-FFF2-40B4-BE49-F238E27FC236}">
-                <a16:creationId xmlns:a16="http://schemas.microsoft.com/office/drawing/2014/main" id="{7A2DDC26-E0B7-47A4-A346-1B2463F2C77E}"/>
+                <a16:creationId xmlns:a16="http://schemas.microsoft.com/office/drawing/2014/main" id="{2DCFA060-C9C7-410F-8D45-1961E0FDB4FD}"/>
               </a:ext>
             </a:extLst>
           </p:cNvPr>
@@ -8495,7 +8490,7 @@
                   <a:srgbClr val="B7791F"/>
                 </a:solidFill>
               </a:rPr>
-              <a:t>PLANNED</a:t>
+              <a:t>CACHED</a:t>
             </a:r>
           </a:p>
         </p:txBody>
@@ -8505,7 +8500,7 @@
           <p:cNvPr id="29" name="">
             <a:extLst xmlns:a="http://schemas.openxmlformats.org/drawingml/2006/main">
               <a:ext uri="{FF2B5EF4-FFF2-40B4-BE49-F238E27FC236}">
-                <a16:creationId xmlns:a16="http://schemas.microsoft.com/office/drawing/2014/main" id="{76D08839-B5D3-4622-BD4D-9FF63B9F757E}"/>
+                <a16:creationId xmlns:a16="http://schemas.microsoft.com/office/drawing/2014/main" id="{E59F1369-3019-437F-87DA-37B647E0A16C}"/>
               </a:ext>
             </a:extLst>
           </p:cNvPr>
@@ -8545,7 +8540,7 @@
                   <a:srgbClr val="243B53"/>
                 </a:solidFill>
               </a:rPr>
-              <a:t>Final witnesses, authoritative traces, and exact policy citations will be captured only from the verified build.</a:t>
+              <a:t>Current record: 3 baseline findings. Final witnesses, traces, and citations still require the frozen browser capture.</a:t>
             </a:r>
           </a:p>
         </p:txBody>
@@ -8553,7 +8548,7 @@
     </p:spTree>
     <p:extLst>
       <p:ext uri="{BB962C8B-B14F-4D97-AF65-F5344CB8AC3E}">
-        <p14:creationId xmlns:p14="http://schemas.microsoft.com/office/powerpoint/2010/main" val="1019433295"/>
+        <p14:creationId xmlns:p14="http://schemas.microsoft.com/office/powerpoint/2010/main" val="314726928"/>
       </p:ext>
     </p:extLst>
   </p:cSld>
@@ -8584,7 +8579,7 @@
           <p:cNvPr id="23" name="">
             <a:extLst xmlns:a="http://schemas.openxmlformats.org/drawingml/2006/main">
               <a:ext uri="{FF2B5EF4-FFF2-40B4-BE49-F238E27FC236}">
-                <a16:creationId xmlns:a16="http://schemas.microsoft.com/office/drawing/2014/main" id="{A1859ED9-2DAE-4B5E-B601-C0A21524C7D3}"/>
+                <a16:creationId xmlns:a16="http://schemas.microsoft.com/office/drawing/2014/main" id="{0169055C-C8B0-48D5-A7F9-225BAA6CB077}"/>
               </a:ext>
             </a:extLst>
           </p:cNvPr>
@@ -8615,7 +8610,7 @@
           <p:cNvPr id="2" name="">
             <a:extLst xmlns:a="http://schemas.openxmlformats.org/drawingml/2006/main">
               <a:ext uri="{FF2B5EF4-FFF2-40B4-BE49-F238E27FC236}">
-                <a16:creationId xmlns:a16="http://schemas.microsoft.com/office/drawing/2014/main" id="{C92713E9-F3D4-4B00-B3BE-4CA89BA86E4A}"/>
+                <a16:creationId xmlns:a16="http://schemas.microsoft.com/office/drawing/2014/main" id="{E8152208-59D1-474B-95AC-1AFCC0E7CA22}"/>
               </a:ext>
             </a:extLst>
           </p:cNvPr>
@@ -8655,7 +8650,7 @@
                   <a:srgbClr val="0F766E"/>
                 </a:solidFill>
               </a:rPr>
-              <a:t>EVIDENCE PLAN</a:t>
+              <a:t>MEASURED CACHED REHEARSAL · SYNTHETIC</a:t>
             </a:r>
           </a:p>
         </p:txBody>
@@ -8665,7 +8660,7 @@
           <p:cNvPr id="3" name="">
             <a:extLst xmlns:a="http://schemas.openxmlformats.org/drawingml/2006/main">
               <a:ext uri="{FF2B5EF4-FFF2-40B4-BE49-F238E27FC236}">
-                <a16:creationId xmlns:a16="http://schemas.microsoft.com/office/drawing/2014/main" id="{391F9671-D09D-4918-8FA5-9E4FCE5F34AC}"/>
+                <a16:creationId xmlns:a16="http://schemas.microsoft.com/office/drawing/2014/main" id="{596B7D38-7307-4D26-9354-872726297732}"/>
               </a:ext>
             </a:extLst>
           </p:cNvPr>
@@ -8715,7 +8710,7 @@
           <p:cNvPr id="4" name="">
             <a:extLst xmlns:a="http://schemas.openxmlformats.org/drawingml/2006/main">
               <a:ext uri="{FF2B5EF4-FFF2-40B4-BE49-F238E27FC236}">
-                <a16:creationId xmlns:a16="http://schemas.microsoft.com/office/drawing/2014/main" id="{9135FD3B-9F36-45F8-8049-FF1B09AF444F}"/>
+                <a16:creationId xmlns:a16="http://schemas.microsoft.com/office/drawing/2014/main" id="{57C1188C-A127-44AA-972B-FD42CCD07C39}"/>
               </a:ext>
             </a:extLst>
           </p:cNvPr>
@@ -8746,7 +8741,7 @@
           <p:cNvPr id="5" name="">
             <a:extLst xmlns:a="http://schemas.openxmlformats.org/drawingml/2006/main">
               <a:ext uri="{FF2B5EF4-FFF2-40B4-BE49-F238E27FC236}">
-                <a16:creationId xmlns:a16="http://schemas.microsoft.com/office/drawing/2014/main" id="{39183846-064D-4BB8-A814-8295194F4638}"/>
+                <a16:creationId xmlns:a16="http://schemas.microsoft.com/office/drawing/2014/main" id="{971DFF57-A320-461F-85F2-D9200AA843E9}"/>
               </a:ext>
             </a:extLst>
           </p:cNvPr>
@@ -8796,7 +8791,7 @@
           <p:cNvPr id="6" name="">
             <a:extLst xmlns:a="http://schemas.openxmlformats.org/drawingml/2006/main">
               <a:ext uri="{FF2B5EF4-FFF2-40B4-BE49-F238E27FC236}">
-                <a16:creationId xmlns:a16="http://schemas.microsoft.com/office/drawing/2014/main" id="{700627D9-6F1F-417C-AE21-E45B0C1079EB}"/>
+                <a16:creationId xmlns:a16="http://schemas.microsoft.com/office/drawing/2014/main" id="{D6BEEAF2-858A-4E6D-B3BB-08A83439D723}"/>
               </a:ext>
             </a:extLst>
           </p:cNvPr>
@@ -8836,7 +8831,7 @@
                   <a:srgbClr val="102A43"/>
                 </a:solidFill>
               </a:rPr>
-              <a:t>Measured results wait for a frozen evidence chain</a:t>
+              <a:t>3 findings become 0; all seven gates pass</a:t>
             </a:r>
           </a:p>
         </p:txBody>
@@ -8846,7 +8841,7 @@
           <p:cNvPr id="7" name="">
             <a:extLst xmlns:a="http://schemas.openxmlformats.org/drawingml/2006/main">
               <a:ext uri="{FF2B5EF4-FFF2-40B4-BE49-F238E27FC236}">
-                <a16:creationId xmlns:a16="http://schemas.microsoft.com/office/drawing/2014/main" id="{81817547-5CCF-4753-803B-9A713E457003}"/>
+                <a16:creationId xmlns:a16="http://schemas.microsoft.com/office/drawing/2014/main" id="{7964148C-A8F1-4DF3-A065-898E53D91F9F}"/>
               </a:ext>
             </a:extLst>
           </p:cNvPr>
@@ -8858,7 +8853,7 @@
         <p:spPr>
           <a:xfrm xmlns:a="http://schemas.openxmlformats.org/drawingml/2006/main">
             <a:off x="666750" y="1504950"/>
-            <a:ext cx="2419350" cy="323850"/>
+            <a:ext cx="3028950" cy="323850"/>
           </a:xfrm>
           <a:prstGeom xmlns:a="http://schemas.openxmlformats.org/drawingml/2006/main" prst="roundRect">
             <a:avLst>
@@ -8890,7 +8885,7 @@
                   <a:srgbClr val="B7791F"/>
                 </a:solidFill>
               </a:rPr>
-              <a:t>MEASURED RESULTS: PENDING</a:t>
+              <a:t>NOT FROZEN · NOT BLIND-ELIGIBLE</a:t>
             </a:r>
           </a:p>
         </p:txBody>
@@ -8900,7 +8895,7 @@
           <p:cNvPr id="8" name="">
             <a:extLst xmlns:a="http://schemas.openxmlformats.org/drawingml/2006/main">
               <a:ext uri="{FF2B5EF4-FFF2-40B4-BE49-F238E27FC236}">
-                <a16:creationId xmlns:a16="http://schemas.microsoft.com/office/drawing/2014/main" id="{DD8BFC31-6EED-4F12-9D89-1789123A3A87}"/>
+                <a16:creationId xmlns:a16="http://schemas.microsoft.com/office/drawing/2014/main" id="{778A20BC-EB8B-401B-8E70-6D3BB94BD1B0}"/>
               </a:ext>
             </a:extLst>
           </p:cNvPr>
@@ -8935,7 +8930,7 @@
           <p:cNvPr id="9" name="">
             <a:extLst xmlns:a="http://schemas.openxmlformats.org/drawingml/2006/main">
               <a:ext uri="{FF2B5EF4-FFF2-40B4-BE49-F238E27FC236}">
-                <a16:creationId xmlns:a16="http://schemas.microsoft.com/office/drawing/2014/main" id="{B89F2149-44D2-4ABC-A2F6-B8C01BC4E53D}"/>
+                <a16:creationId xmlns:a16="http://schemas.microsoft.com/office/drawing/2014/main" id="{091CEA89-A260-4EB9-B9E0-FC22D0B297B8}"/>
               </a:ext>
             </a:extLst>
           </p:cNvPr>
@@ -8975,7 +8970,7 @@
                   <a:srgbClr val="0F766E"/>
                 </a:solidFill>
               </a:rPr>
-              <a:t>DEVELOPMENT</a:t>
+              <a:t>BEFORE</a:t>
             </a:r>
           </a:p>
         </p:txBody>
@@ -8985,7 +8980,7 @@
           <p:cNvPr id="10" name="">
             <a:extLst xmlns:a="http://schemas.openxmlformats.org/drawingml/2006/main">
               <a:ext uri="{FF2B5EF4-FFF2-40B4-BE49-F238E27FC236}">
-                <a16:creationId xmlns:a16="http://schemas.microsoft.com/office/drawing/2014/main" id="{79A59213-BA87-42EB-94E6-62628C8B651F}"/>
+                <a16:creationId xmlns:a16="http://schemas.microsoft.com/office/drawing/2014/main" id="{1780A5D2-FD34-46F4-A8FB-72A3024BDB19}"/>
               </a:ext>
             </a:extLst>
           </p:cNvPr>
@@ -9025,7 +9020,7 @@
                   <a:srgbClr val="102A43"/>
                 </a:solidFill>
               </a:rPr>
-              <a:t>Known synthetic defects</a:t>
+              <a:t>3 findings</a:t>
             </a:r>
           </a:p>
         </p:txBody>
@@ -9035,7 +9030,7 @@
           <p:cNvPr id="11" name="">
             <a:extLst xmlns:a="http://schemas.openxmlformats.org/drawingml/2006/main">
               <a:ext uri="{FF2B5EF4-FFF2-40B4-BE49-F238E27FC236}">
-                <a16:creationId xmlns:a16="http://schemas.microsoft.com/office/drawing/2014/main" id="{BFB6EFDC-37AB-4F86-9D0E-23D9CC3203C3}"/>
+                <a16:creationId xmlns:a16="http://schemas.microsoft.com/office/drawing/2014/main" id="{2ADCA057-B5EA-45A7-B1A1-407A4A45A7B8}"/>
               </a:ext>
             </a:extLst>
           </p:cNvPr>
@@ -9075,7 +9070,7 @@
                   <a:srgbClr val="627D8C"/>
                 </a:solidFill>
               </a:rPr>
-              <a:t>Exact finding match</a:t>
+              <a:t>10 scenarios</a:t>
             </a:r>
           </a:p>
           <a:p xmlns:a="http://schemas.openxmlformats.org/drawingml/2006/main">
@@ -9092,7 +9087,7 @@
                   <a:srgbClr val="627D8C"/>
                 </a:solidFill>
               </a:rPr>
-              <a:t>Citation integrity</a:t>
+              <a:t>12 inconclusive assertions</a:t>
             </a:r>
           </a:p>
           <a:p xmlns:a="http://schemas.openxmlformats.org/drawingml/2006/main">
@@ -9109,7 +9104,7 @@
                   <a:srgbClr val="627D8C"/>
                 </a:solidFill>
               </a:rPr>
-              <a:t>Coverage + replay</a:t>
+              <a:t>11 gaps · 1 conflict</a:t>
             </a:r>
           </a:p>
           <a:p xmlns:a="http://schemas.openxmlformats.org/drawingml/2006/main">
@@ -9126,7 +9121,7 @@
                   <a:srgbClr val="627D8C"/>
                 </a:solidFill>
               </a:rPr>
-              <a:t>Same-suite patch gates</a:t>
+              <a:t>Minimum coverage satisfied</a:t>
             </a:r>
           </a:p>
         </p:txBody>
@@ -9136,7 +9131,7 @@
           <p:cNvPr id="12" name="">
             <a:extLst xmlns:a="http://schemas.openxmlformats.org/drawingml/2006/main">
               <a:ext uri="{FF2B5EF4-FFF2-40B4-BE49-F238E27FC236}">
-                <a16:creationId xmlns:a16="http://schemas.microsoft.com/office/drawing/2014/main" id="{29494C37-6795-45A9-AD07-472CA7772910}"/>
+                <a16:creationId xmlns:a16="http://schemas.microsoft.com/office/drawing/2014/main" id="{469A75B9-3FF4-41DE-B9C1-55105F941CB1}"/>
               </a:ext>
             </a:extLst>
           </p:cNvPr>
@@ -9171,7 +9166,7 @@
           <p:cNvPr id="13" name="">
             <a:extLst xmlns:a="http://schemas.openxmlformats.org/drawingml/2006/main">
               <a:ext uri="{FF2B5EF4-FFF2-40B4-BE49-F238E27FC236}">
-                <a16:creationId xmlns:a16="http://schemas.microsoft.com/office/drawing/2014/main" id="{6BF82353-F85D-4833-9CEF-492DC687B2AB}"/>
+                <a16:creationId xmlns:a16="http://schemas.microsoft.com/office/drawing/2014/main" id="{9AB2D82E-A140-4F8F-ABF9-A6E4D789AC3A}"/>
               </a:ext>
             </a:extLst>
           </p:cNvPr>
@@ -9211,7 +9206,7 @@
                   <a:srgbClr val="0F766E"/>
                 </a:solidFill>
               </a:rPr>
-              <a:t>CORRECTED CONTROL</a:t>
+              <a:t>AFTER</a:t>
             </a:r>
           </a:p>
         </p:txBody>
@@ -9221,7 +9216,7 @@
           <p:cNvPr id="14" name="">
             <a:extLst xmlns:a="http://schemas.openxmlformats.org/drawingml/2006/main">
               <a:ext uri="{FF2B5EF4-FFF2-40B4-BE49-F238E27FC236}">
-                <a16:creationId xmlns:a16="http://schemas.microsoft.com/office/drawing/2014/main" id="{8259C0F0-E572-42BA-80E4-702E974A02E5}"/>
+                <a16:creationId xmlns:a16="http://schemas.microsoft.com/office/drawing/2014/main" id="{44A9AD2F-B3B1-4819-89DE-F071A6BA2307}"/>
               </a:ext>
             </a:extLst>
           </p:cNvPr>
@@ -9261,7 +9256,7 @@
                   <a:srgbClr val="102A43"/>
                 </a:solidFill>
               </a:rPr>
-              <a:t>Regression challenge</a:t>
+              <a:t>0 findings</a:t>
             </a:r>
           </a:p>
         </p:txBody>
@@ -9271,7 +9266,7 @@
           <p:cNvPr id="15" name="">
             <a:extLst xmlns:a="http://schemas.openxmlformats.org/drawingml/2006/main">
               <a:ext uri="{FF2B5EF4-FFF2-40B4-BE49-F238E27FC236}">
-                <a16:creationId xmlns:a16="http://schemas.microsoft.com/office/drawing/2014/main" id="{3530ACC7-8868-4B59-9AC1-A6E70B34F902}"/>
+                <a16:creationId xmlns:a16="http://schemas.microsoft.com/office/drawing/2014/main" id="{01FDECEA-C63D-4B2F-94FE-EA544382CDF0}"/>
               </a:ext>
             </a:extLst>
           </p:cNvPr>
@@ -9311,7 +9306,7 @@
                   <a:srgbClr val="627D8C"/>
                 </a:solidFill>
               </a:rPr>
-              <a:t>No confirmed target defect</a:t>
+              <a:t>Same frozen suite</a:t>
             </a:r>
           </a:p>
           <a:p xmlns:a="http://schemas.openxmlformats.org/drawingml/2006/main">
@@ -9328,7 +9323,7 @@
                   <a:srgbClr val="627D8C"/>
                 </a:solidFill>
               </a:rPr>
-              <a:t>Protected assertions</a:t>
+              <a:t>12 passing assertions</a:t>
             </a:r>
           </a:p>
           <a:p xmlns:a="http://schemas.openxmlformats.org/drawingml/2006/main">
@@ -9345,7 +9340,7 @@
                   <a:srgbClr val="627D8C"/>
                 </a:solidFill>
               </a:rPr>
-              <a:t>No new gaps or conflicts</a:t>
+              <a:t>0 gaps · 0 conflicts</a:t>
             </a:r>
           </a:p>
           <a:p xmlns:a="http://schemas.openxmlformats.org/drawingml/2006/main">
@@ -9362,7 +9357,7 @@
                   <a:srgbClr val="627D8C"/>
                 </a:solidFill>
               </a:rPr>
-              <a:t>Same engine + suite</a:t>
+              <a:t>7 / 7 gates true</a:t>
             </a:r>
           </a:p>
         </p:txBody>
@@ -9372,7 +9367,7 @@
           <p:cNvPr id="16" name="">
             <a:extLst xmlns:a="http://schemas.openxmlformats.org/drawingml/2006/main">
               <a:ext uri="{FF2B5EF4-FFF2-40B4-BE49-F238E27FC236}">
-                <a16:creationId xmlns:a16="http://schemas.microsoft.com/office/drawing/2014/main" id="{2BA8D7DB-8CC3-42F4-9CEE-7F3CA937F455}"/>
+                <a16:creationId xmlns:a16="http://schemas.microsoft.com/office/drawing/2014/main" id="{B0A10DCC-5020-45A4-B40B-37B8903F3826}"/>
               </a:ext>
             </a:extLst>
           </p:cNvPr>
@@ -9407,7 +9402,7 @@
           <p:cNvPr id="17" name="">
             <a:extLst xmlns:a="http://schemas.openxmlformats.org/drawingml/2006/main">
               <a:ext uri="{FF2B5EF4-FFF2-40B4-BE49-F238E27FC236}">
-                <a16:creationId xmlns:a16="http://schemas.microsoft.com/office/drawing/2014/main" id="{271EEC19-B05C-4DDC-853C-1A18C138206C}"/>
+                <a16:creationId xmlns:a16="http://schemas.microsoft.com/office/drawing/2014/main" id="{7C935CB1-8010-4393-A9E3-937861D5B67E}"/>
               </a:ext>
             </a:extLst>
           </p:cNvPr>
@@ -9447,7 +9442,7 @@
                   <a:srgbClr val="B7791F"/>
                 </a:solidFill>
               </a:rPr>
-              <a:t>BLIND</a:t>
+              <a:t>PROVENANCE</a:t>
             </a:r>
           </a:p>
         </p:txBody>
@@ -9457,7 +9452,7 @@
           <p:cNvPr id="18" name="">
             <a:extLst xmlns:a="http://schemas.openxmlformats.org/drawingml/2006/main">
               <a:ext uri="{FF2B5EF4-FFF2-40B4-BE49-F238E27FC236}">
-                <a16:creationId xmlns:a16="http://schemas.microsoft.com/office/drawing/2014/main" id="{7C143D60-9098-437C-8515-14F40A2923C1}"/>
+                <a16:creationId xmlns:a16="http://schemas.microsoft.com/office/drawing/2014/main" id="{E715120B-1783-4CC6-A90C-063EDDBD16F4}"/>
               </a:ext>
             </a:extLst>
           </p:cNvPr>
@@ -9497,7 +9492,7 @@
                   <a:srgbClr val="102A43"/>
                 </a:solidFill>
               </a:rPr>
-              <a:t>Late-sealed candidate</a:t>
+              <a:t>Cached rehearsal</a:t>
             </a:r>
           </a:p>
         </p:txBody>
@@ -9507,7 +9502,7 @@
           <p:cNvPr id="19" name="">
             <a:extLst xmlns:a="http://schemas.openxmlformats.org/drawingml/2006/main">
               <a:ext uri="{FF2B5EF4-FFF2-40B4-BE49-F238E27FC236}">
-                <a16:creationId xmlns:a16="http://schemas.microsoft.com/office/drawing/2014/main" id="{1D5D0439-2D38-4DA2-B041-92066F39FAE8}"/>
+                <a16:creationId xmlns:a16="http://schemas.microsoft.com/office/drawing/2014/main" id="{4EC9F080-0EBA-494F-97AE-1829FB5AA83E}"/>
               </a:ext>
             </a:extLst>
           </p:cNvPr>
@@ -9547,7 +9542,7 @@
                   <a:srgbClr val="627D8C"/>
                 </a:solidFill>
               </a:rPr>
-              <a:t>Human review pending</a:t>
+              <a:t>4 scripted model responses</a:t>
             </a:r>
           </a:p>
           <a:p xmlns:a="http://schemas.openxmlformats.org/drawingml/2006/main">
@@ -9564,7 +9559,7 @@
                   <a:srgbClr val="627D8C"/>
                 </a:solidFill>
               </a:rPr>
-              <a:t>Scoring-ineligible</a:t>
+              <a:t>0 actual provider calls</a:t>
             </a:r>
           </a:p>
           <a:p xmlns:a="http://schemas.openxmlformats.org/drawingml/2006/main">
@@ -9581,7 +9576,7 @@
                   <a:srgbClr val="627D8C"/>
                 </a:solidFill>
               </a:rPr>
-              <a:t>First-run custody required</a:t>
+              <a:t>Synthetic data</a:t>
             </a:r>
           </a:p>
           <a:p xmlns:a="http://schemas.openxmlformats.org/drawingml/2006/main">
@@ -9598,7 +9593,7 @@
                   <a:srgbClr val="627D8C"/>
                 </a:solidFill>
               </a:rPr>
-              <a:t>No headline claim</a:t>
+              <a:t>Blind-scoring-ineligible</a:t>
             </a:r>
           </a:p>
         </p:txBody>
@@ -9608,7 +9603,7 @@
           <p:cNvPr id="20" name="">
             <a:extLst xmlns:a="http://schemas.openxmlformats.org/drawingml/2006/main">
               <a:ext uri="{FF2B5EF4-FFF2-40B4-BE49-F238E27FC236}">
-                <a16:creationId xmlns:a16="http://schemas.microsoft.com/office/drawing/2014/main" id="{0A059E7B-F084-4851-B1F0-072A02F96F7B}"/>
+                <a16:creationId xmlns:a16="http://schemas.microsoft.com/office/drawing/2014/main" id="{83D98CA5-BD98-4426-8D95-D6B0E4E3B942}"/>
               </a:ext>
             </a:extLst>
           </p:cNvPr>
@@ -9648,7 +9643,7 @@
                   <a:srgbClr val="627D8C"/>
                 </a:solidFill>
               </a:rPr>
-              <a:t>Release chain</a:t>
+              <a:t>Final chain</a:t>
             </a:r>
           </a:p>
         </p:txBody>
@@ -9658,7 +9653,7 @@
           <p:cNvPr id="21" name="">
             <a:extLst xmlns:a="http://schemas.openxmlformats.org/drawingml/2006/main">
               <a:ext uri="{FF2B5EF4-FFF2-40B4-BE49-F238E27FC236}">
-                <a16:creationId xmlns:a16="http://schemas.microsoft.com/office/drawing/2014/main" id="{8AA54526-CDD2-4A0A-8BEA-C3F2DACA3651}"/>
+                <a16:creationId xmlns:a16="http://schemas.microsoft.com/office/drawing/2014/main" id="{44AC8C7B-8AA1-4EC2-AB9F-947937B5CA8F}"/>
               </a:ext>
             </a:extLst>
           </p:cNvPr>
@@ -9698,7 +9693,7 @@
                   <a:srgbClr val="243B53"/>
                 </a:solidFill>
               </a:rPr>
-              <a:t>Gate B report  →  demo-core-v1  →  6-hour freeze  →  evidence capture  →  reviewer checks</a:t>
+              <a:t>Gate B  →  demo-core-v1  →  6-hour freeze  →  browser capture  →  two human reviews</a:t>
             </a:r>
           </a:p>
         </p:txBody>
@@ -9708,7 +9703,7 @@
           <p:cNvPr id="22" name="">
             <a:extLst xmlns:a="http://schemas.openxmlformats.org/drawingml/2006/main">
               <a:ext uri="{FF2B5EF4-FFF2-40B4-BE49-F238E27FC236}">
-                <a16:creationId xmlns:a16="http://schemas.microsoft.com/office/drawing/2014/main" id="{487F9452-B833-462B-91D0-DE9089251415}"/>
+                <a16:creationId xmlns:a16="http://schemas.microsoft.com/office/drawing/2014/main" id="{BE2DB7D9-0691-445A-B782-9B7077276DD0}"/>
               </a:ext>
             </a:extLst>
           </p:cNvPr>
@@ -9748,7 +9743,7 @@
                   <a:srgbClr val="0F766E"/>
                 </a:solidFill>
               </a:rPr>
-              <a:t>Results will be reported with their frozen suite, engine, and source evidence.</a:t>
+              <a:t>Until that chain completes, these numbers remain rehearsal evidence — not headline blind results.</a:t>
             </a:r>
           </a:p>
         </p:txBody>
@@ -9756,7 +9751,7 @@
     </p:spTree>
     <p:extLst>
       <p:ext uri="{BB962C8B-B14F-4D97-AF65-F5344CB8AC3E}">
-        <p14:creationId xmlns:p14="http://schemas.microsoft.com/office/powerpoint/2010/main" val="1629540789"/>
+        <p14:creationId xmlns:p14="http://schemas.microsoft.com/office/powerpoint/2010/main" val="974564774"/>
       </p:ext>
     </p:extLst>
   </p:cSld>
@@ -9787,7 +9782,7 @@
           <p:cNvPr id="23" name="">
             <a:extLst xmlns:a="http://schemas.openxmlformats.org/drawingml/2006/main">
               <a:ext uri="{FF2B5EF4-FFF2-40B4-BE49-F238E27FC236}">
-                <a16:creationId xmlns:a16="http://schemas.microsoft.com/office/drawing/2014/main" id="{AC47808C-75D2-414D-8E4A-E8071FE77511}"/>
+                <a16:creationId xmlns:a16="http://schemas.microsoft.com/office/drawing/2014/main" id="{7E3EFF88-1254-4EAF-A490-3DFDAB7B43A4}"/>
               </a:ext>
             </a:extLst>
           </p:cNvPr>
@@ -9818,7 +9813,7 @@
           <p:cNvPr id="2" name="">
             <a:extLst xmlns:a="http://schemas.openxmlformats.org/drawingml/2006/main">
               <a:ext uri="{FF2B5EF4-FFF2-40B4-BE49-F238E27FC236}">
-                <a16:creationId xmlns:a16="http://schemas.microsoft.com/office/drawing/2014/main" id="{D138AD6C-093C-47FE-8350-2A122399E707}"/>
+                <a16:creationId xmlns:a16="http://schemas.microsoft.com/office/drawing/2014/main" id="{96DE1ED0-95FB-4A43-817C-18A51F4C6B09}"/>
               </a:ext>
             </a:extLst>
           </p:cNvPr>
@@ -9868,7 +9863,7 @@
           <p:cNvPr id="3" name="">
             <a:extLst xmlns:a="http://schemas.openxmlformats.org/drawingml/2006/main">
               <a:ext uri="{FF2B5EF4-FFF2-40B4-BE49-F238E27FC236}">
-                <a16:creationId xmlns:a16="http://schemas.microsoft.com/office/drawing/2014/main" id="{582AD39F-1325-418A-947C-969AA77C7C33}"/>
+                <a16:creationId xmlns:a16="http://schemas.microsoft.com/office/drawing/2014/main" id="{8C95B3B9-920B-4FE0-A11F-37160743B9BB}"/>
               </a:ext>
             </a:extLst>
           </p:cNvPr>
@@ -9918,7 +9913,7 @@
           <p:cNvPr id="4" name="">
             <a:extLst xmlns:a="http://schemas.openxmlformats.org/drawingml/2006/main">
               <a:ext uri="{FF2B5EF4-FFF2-40B4-BE49-F238E27FC236}">
-                <a16:creationId xmlns:a16="http://schemas.microsoft.com/office/drawing/2014/main" id="{C56A2D72-4727-41C0-9838-DA4F57AC767B}"/>
+                <a16:creationId xmlns:a16="http://schemas.microsoft.com/office/drawing/2014/main" id="{D137B0E0-7867-4350-A5DA-0641EA5004D0}"/>
               </a:ext>
             </a:extLst>
           </p:cNvPr>
@@ -9949,7 +9944,7 @@
           <p:cNvPr id="5" name="">
             <a:extLst xmlns:a="http://schemas.openxmlformats.org/drawingml/2006/main">
               <a:ext uri="{FF2B5EF4-FFF2-40B4-BE49-F238E27FC236}">
-                <a16:creationId xmlns:a16="http://schemas.microsoft.com/office/drawing/2014/main" id="{FD27C001-37D7-444C-BEE2-4DFC868895D3}"/>
+                <a16:creationId xmlns:a16="http://schemas.microsoft.com/office/drawing/2014/main" id="{C8515C52-137E-4BE4-B050-CDB32807469E}"/>
               </a:ext>
             </a:extLst>
           </p:cNvPr>
@@ -9999,7 +9994,7 @@
           <p:cNvPr id="6" name="">
             <a:extLst xmlns:a="http://schemas.openxmlformats.org/drawingml/2006/main">
               <a:ext uri="{FF2B5EF4-FFF2-40B4-BE49-F238E27FC236}">
-                <a16:creationId xmlns:a16="http://schemas.microsoft.com/office/drawing/2014/main" id="{EB878504-89E5-4891-936A-F32E9C53A216}"/>
+                <a16:creationId xmlns:a16="http://schemas.microsoft.com/office/drawing/2014/main" id="{67347A34-8F12-4F27-9E56-74672C76CFD5}"/>
               </a:ext>
             </a:extLst>
           </p:cNvPr>
@@ -10049,7 +10044,7 @@
           <p:cNvPr id="7" name="">
             <a:extLst xmlns:a="http://schemas.openxmlformats.org/drawingml/2006/main">
               <a:ext uri="{FF2B5EF4-FFF2-40B4-BE49-F238E27FC236}">
-                <a16:creationId xmlns:a16="http://schemas.microsoft.com/office/drawing/2014/main" id="{B3FB6180-A9E9-4AAD-8EE1-204B25365BDD}"/>
+                <a16:creationId xmlns:a16="http://schemas.microsoft.com/office/drawing/2014/main" id="{1C310F07-755B-42EB-9DDA-08DD7B48225B}"/>
               </a:ext>
             </a:extLst>
           </p:cNvPr>
@@ -10099,7 +10094,7 @@
           <p:cNvPr id="8" name="">
             <a:extLst xmlns:a="http://schemas.openxmlformats.org/drawingml/2006/main">
               <a:ext uri="{FF2B5EF4-FFF2-40B4-BE49-F238E27FC236}">
-                <a16:creationId xmlns:a16="http://schemas.microsoft.com/office/drawing/2014/main" id="{DB570758-6BFA-44E9-8A86-3CE57D691219}"/>
+                <a16:creationId xmlns:a16="http://schemas.microsoft.com/office/drawing/2014/main" id="{422EA2B9-622E-41B8-8E8D-E55895280884}"/>
               </a:ext>
             </a:extLst>
           </p:cNvPr>
@@ -10149,7 +10144,7 @@
           <p:cNvPr id="9" name="">
             <a:extLst xmlns:a="http://schemas.openxmlformats.org/drawingml/2006/main">
               <a:ext uri="{FF2B5EF4-FFF2-40B4-BE49-F238E27FC236}">
-                <a16:creationId xmlns:a16="http://schemas.microsoft.com/office/drawing/2014/main" id="{1B1B9E18-6F87-4E19-B171-17F6C30B05F2}"/>
+                <a16:creationId xmlns:a16="http://schemas.microsoft.com/office/drawing/2014/main" id="{A1219EE8-5FFB-4308-8241-8FFD6BE23876}"/>
               </a:ext>
             </a:extLst>
           </p:cNvPr>
@@ -10180,7 +10175,7 @@
           <p:cNvPr id="10" name="">
             <a:extLst xmlns:a="http://schemas.openxmlformats.org/drawingml/2006/main">
               <a:ext uri="{FF2B5EF4-FFF2-40B4-BE49-F238E27FC236}">
-                <a16:creationId xmlns:a16="http://schemas.microsoft.com/office/drawing/2014/main" id="{DC0F3316-E3F6-4F45-A6C7-73304C0A62A6}"/>
+                <a16:creationId xmlns:a16="http://schemas.microsoft.com/office/drawing/2014/main" id="{B6C08E99-6BDC-4FFE-9091-760E2DD81AF8}"/>
               </a:ext>
             </a:extLst>
           </p:cNvPr>
@@ -10230,7 +10225,7 @@
           <p:cNvPr id="11" name="">
             <a:extLst xmlns:a="http://schemas.openxmlformats.org/drawingml/2006/main">
               <a:ext uri="{FF2B5EF4-FFF2-40B4-BE49-F238E27FC236}">
-                <a16:creationId xmlns:a16="http://schemas.microsoft.com/office/drawing/2014/main" id="{F71AD072-844D-48DB-BFC8-7198924D02D0}"/>
+                <a16:creationId xmlns:a16="http://schemas.microsoft.com/office/drawing/2014/main" id="{EE077835-9645-4C79-8AF7-ED497D2CFB76}"/>
               </a:ext>
             </a:extLst>
           </p:cNvPr>
@@ -10284,7 +10279,7 @@
           <p:cNvPr id="12" name="">
             <a:extLst xmlns:a="http://schemas.openxmlformats.org/drawingml/2006/main">
               <a:ext uri="{FF2B5EF4-FFF2-40B4-BE49-F238E27FC236}">
-                <a16:creationId xmlns:a16="http://schemas.microsoft.com/office/drawing/2014/main" id="{A58CA782-3E8C-427D-B1B1-DBDCC3AF9620}"/>
+                <a16:creationId xmlns:a16="http://schemas.microsoft.com/office/drawing/2014/main" id="{A228B461-2341-4D36-8143-4B80F11AA2EB}"/>
               </a:ext>
             </a:extLst>
           </p:cNvPr>
@@ -10334,7 +10329,7 @@
           <p:cNvPr id="13" name="">
             <a:extLst xmlns:a="http://schemas.openxmlformats.org/drawingml/2006/main">
               <a:ext uri="{FF2B5EF4-FFF2-40B4-BE49-F238E27FC236}">
-                <a16:creationId xmlns:a16="http://schemas.microsoft.com/office/drawing/2014/main" id="{69F689EF-E6E6-417D-B00A-163B565A889E}"/>
+                <a16:creationId xmlns:a16="http://schemas.microsoft.com/office/drawing/2014/main" id="{B7631AF2-9FC2-4FA5-A6AB-0274AC056E7D}"/>
               </a:ext>
             </a:extLst>
           </p:cNvPr>
@@ -10384,7 +10379,7 @@
           <p:cNvPr id="14" name="">
             <a:extLst xmlns:a="http://schemas.openxmlformats.org/drawingml/2006/main">
               <a:ext uri="{FF2B5EF4-FFF2-40B4-BE49-F238E27FC236}">
-                <a16:creationId xmlns:a16="http://schemas.microsoft.com/office/drawing/2014/main" id="{194CB1ED-3958-4510-85E9-CC46A4B141AF}"/>
+                <a16:creationId xmlns:a16="http://schemas.microsoft.com/office/drawing/2014/main" id="{D4105BF7-83F0-4BBE-98F6-A2C192D76C26}"/>
               </a:ext>
             </a:extLst>
           </p:cNvPr>
@@ -10438,7 +10433,7 @@
           <p:cNvPr id="15" name="">
             <a:extLst xmlns:a="http://schemas.openxmlformats.org/drawingml/2006/main">
               <a:ext uri="{FF2B5EF4-FFF2-40B4-BE49-F238E27FC236}">
-                <a16:creationId xmlns:a16="http://schemas.microsoft.com/office/drawing/2014/main" id="{743D84D2-E03B-4E7A-81FC-588502F6E262}"/>
+                <a16:creationId xmlns:a16="http://schemas.microsoft.com/office/drawing/2014/main" id="{AF33AA69-0A19-4064-974B-084D7DD70F1D}"/>
               </a:ext>
             </a:extLst>
           </p:cNvPr>
@@ -10488,7 +10483,7 @@
           <p:cNvPr id="16" name="">
             <a:extLst xmlns:a="http://schemas.openxmlformats.org/drawingml/2006/main">
               <a:ext uri="{FF2B5EF4-FFF2-40B4-BE49-F238E27FC236}">
-                <a16:creationId xmlns:a16="http://schemas.microsoft.com/office/drawing/2014/main" id="{997B72E1-0B2D-44B9-86EC-2D1B6820A74C}"/>
+                <a16:creationId xmlns:a16="http://schemas.microsoft.com/office/drawing/2014/main" id="{879B1C6F-0646-48F4-B2B3-9D57364E2896}"/>
               </a:ext>
             </a:extLst>
           </p:cNvPr>
@@ -10538,7 +10533,7 @@
           <p:cNvPr id="17" name="">
             <a:extLst xmlns:a="http://schemas.openxmlformats.org/drawingml/2006/main">
               <a:ext uri="{FF2B5EF4-FFF2-40B4-BE49-F238E27FC236}">
-                <a16:creationId xmlns:a16="http://schemas.microsoft.com/office/drawing/2014/main" id="{60741CCC-C815-443C-963B-C2EA1EDA0B1E}"/>
+                <a16:creationId xmlns:a16="http://schemas.microsoft.com/office/drawing/2014/main" id="{D3AE0E0A-5FC4-4A90-90CC-14E65BBC31F3}"/>
               </a:ext>
             </a:extLst>
           </p:cNvPr>
@@ -10592,7 +10587,7 @@
           <p:cNvPr id="18" name="">
             <a:extLst xmlns:a="http://schemas.openxmlformats.org/drawingml/2006/main">
               <a:ext uri="{FF2B5EF4-FFF2-40B4-BE49-F238E27FC236}">
-                <a16:creationId xmlns:a16="http://schemas.microsoft.com/office/drawing/2014/main" id="{FADD0D70-D55B-4E48-B056-BDF5244B88F7}"/>
+                <a16:creationId xmlns:a16="http://schemas.microsoft.com/office/drawing/2014/main" id="{C0465556-3375-4ABF-A1C1-986DF885D75A}"/>
               </a:ext>
             </a:extLst>
           </p:cNvPr>
@@ -10642,7 +10637,7 @@
           <p:cNvPr id="19" name="">
             <a:extLst xmlns:a="http://schemas.openxmlformats.org/drawingml/2006/main">
               <a:ext uri="{FF2B5EF4-FFF2-40B4-BE49-F238E27FC236}">
-                <a16:creationId xmlns:a16="http://schemas.microsoft.com/office/drawing/2014/main" id="{F59609B7-7256-400A-B37B-2255FF762088}"/>
+                <a16:creationId xmlns:a16="http://schemas.microsoft.com/office/drawing/2014/main" id="{FDB3BDCF-6F17-469C-B1E5-8DF9DE623EFF}"/>
               </a:ext>
             </a:extLst>
           </p:cNvPr>
@@ -10692,7 +10687,7 @@
           <p:cNvPr id="20" name="">
             <a:extLst xmlns:a="http://schemas.openxmlformats.org/drawingml/2006/main">
               <a:ext uri="{FF2B5EF4-FFF2-40B4-BE49-F238E27FC236}">
-                <a16:creationId xmlns:a16="http://schemas.microsoft.com/office/drawing/2014/main" id="{82205ABD-74FC-46D4-A70A-C4F9D68CFC7E}"/>
+                <a16:creationId xmlns:a16="http://schemas.microsoft.com/office/drawing/2014/main" id="{F5ED8991-6166-47D7-A34F-7272663E615E}"/>
               </a:ext>
             </a:extLst>
           </p:cNvPr>
@@ -10746,7 +10741,7 @@
           <p:cNvPr id="21" name="">
             <a:extLst xmlns:a="http://schemas.openxmlformats.org/drawingml/2006/main">
               <a:ext uri="{FF2B5EF4-FFF2-40B4-BE49-F238E27FC236}">
-                <a16:creationId xmlns:a16="http://schemas.microsoft.com/office/drawing/2014/main" id="{4B0C2F12-AA6C-4366-873E-E8CC167AB293}"/>
+                <a16:creationId xmlns:a16="http://schemas.microsoft.com/office/drawing/2014/main" id="{AFD4D745-ADCE-4ED4-A461-5DB6BC4BEB2D}"/>
               </a:ext>
             </a:extLst>
           </p:cNvPr>
@@ -10796,7 +10791,7 @@
           <p:cNvPr id="22" name="">
             <a:extLst xmlns:a="http://schemas.openxmlformats.org/drawingml/2006/main">
               <a:ext uri="{FF2B5EF4-FFF2-40B4-BE49-F238E27FC236}">
-                <a16:creationId xmlns:a16="http://schemas.microsoft.com/office/drawing/2014/main" id="{0D2B3BFE-41FA-4324-BCDF-3D5ACE5108CC}"/>
+                <a16:creationId xmlns:a16="http://schemas.microsoft.com/office/drawing/2014/main" id="{64BD0F5C-C129-4201-B381-8894F5039138}"/>
               </a:ext>
             </a:extLst>
           </p:cNvPr>
@@ -10844,7 +10839,7 @@
     </p:spTree>
     <p:extLst>
       <p:ext uri="{BB962C8B-B14F-4D97-AF65-F5344CB8AC3E}">
-        <p14:creationId xmlns:p14="http://schemas.microsoft.com/office/powerpoint/2010/main" val="1292908065"/>
+        <p14:creationId xmlns:p14="http://schemas.microsoft.com/office/powerpoint/2010/main" val="829592114"/>
       </p:ext>
     </p:extLst>
   </p:cSld>
@@ -10875,7 +10870,7 @@
           <p:cNvPr id="14" name="">
             <a:extLst xmlns:a="http://schemas.openxmlformats.org/drawingml/2006/main">
               <a:ext uri="{FF2B5EF4-FFF2-40B4-BE49-F238E27FC236}">
-                <a16:creationId xmlns:a16="http://schemas.microsoft.com/office/drawing/2014/main" id="{21D4FEED-CAC5-4321-82EC-5BBA5ED22441}"/>
+                <a16:creationId xmlns:a16="http://schemas.microsoft.com/office/drawing/2014/main" id="{2D078901-3A7F-48FE-9957-7B01AFFCA37A}"/>
               </a:ext>
             </a:extLst>
           </p:cNvPr>
@@ -10906,7 +10901,7 @@
           <p:cNvPr id="2" name="">
             <a:extLst xmlns:a="http://schemas.openxmlformats.org/drawingml/2006/main">
               <a:ext uri="{FF2B5EF4-FFF2-40B4-BE49-F238E27FC236}">
-                <a16:creationId xmlns:a16="http://schemas.microsoft.com/office/drawing/2014/main" id="{6D064A93-AE4D-459B-AA95-C7D7FD7AAE59}"/>
+                <a16:creationId xmlns:a16="http://schemas.microsoft.com/office/drawing/2014/main" id="{1FB2BED6-F3AB-47FE-95AC-982E1CD2E7AA}"/>
               </a:ext>
             </a:extLst>
           </p:cNvPr>
@@ -10956,7 +10951,7 @@
           <p:cNvPr id="3" name="">
             <a:extLst xmlns:a="http://schemas.openxmlformats.org/drawingml/2006/main">
               <a:ext uri="{FF2B5EF4-FFF2-40B4-BE49-F238E27FC236}">
-                <a16:creationId xmlns:a16="http://schemas.microsoft.com/office/drawing/2014/main" id="{DE13CE0F-7B80-469A-B9D7-00E4A4574824}"/>
+                <a16:creationId xmlns:a16="http://schemas.microsoft.com/office/drawing/2014/main" id="{69D1E40E-E109-44A8-A19E-9E7C83788E83}"/>
               </a:ext>
             </a:extLst>
           </p:cNvPr>
@@ -11023,7 +11018,7 @@
           <p:cNvPr id="4" name="">
             <a:extLst xmlns:a="http://schemas.openxmlformats.org/drawingml/2006/main">
               <a:ext uri="{FF2B5EF4-FFF2-40B4-BE49-F238E27FC236}">
-                <a16:creationId xmlns:a16="http://schemas.microsoft.com/office/drawing/2014/main" id="{01A3C070-5982-4C1D-B551-F487F4871B26}"/>
+                <a16:creationId xmlns:a16="http://schemas.microsoft.com/office/drawing/2014/main" id="{F2D21AD7-B042-4AC4-A58B-311FF2E0D71A}"/>
               </a:ext>
             </a:extLst>
           </p:cNvPr>
@@ -11073,7 +11068,7 @@
           <p:cNvPr id="5" name="">
             <a:extLst xmlns:a="http://schemas.openxmlformats.org/drawingml/2006/main">
               <a:ext uri="{FF2B5EF4-FFF2-40B4-BE49-F238E27FC236}">
-                <a16:creationId xmlns:a16="http://schemas.microsoft.com/office/drawing/2014/main" id="{89515B09-02EF-47B3-B4E7-FD3AEDA93BDD}"/>
+                <a16:creationId xmlns:a16="http://schemas.microsoft.com/office/drawing/2014/main" id="{5CDC3809-9B9E-49B1-B784-935D083A001D}"/>
               </a:ext>
             </a:extLst>
           </p:cNvPr>
@@ -11123,7 +11118,7 @@
           <p:cNvPr id="6" name="">
             <a:extLst xmlns:a="http://schemas.openxmlformats.org/drawingml/2006/main">
               <a:ext uri="{FF2B5EF4-FFF2-40B4-BE49-F238E27FC236}">
-                <a16:creationId xmlns:a16="http://schemas.microsoft.com/office/drawing/2014/main" id="{8290ABE1-7CFC-4D78-A3FC-2AF0D1C0AFB1}"/>
+                <a16:creationId xmlns:a16="http://schemas.microsoft.com/office/drawing/2014/main" id="{AB964055-21FA-4F98-B83B-BE6AF1A25AA4}"/>
               </a:ext>
             </a:extLst>
           </p:cNvPr>
@@ -11154,7 +11149,7 @@
           <p:cNvPr id="7" name="">
             <a:extLst xmlns:a="http://schemas.openxmlformats.org/drawingml/2006/main">
               <a:ext uri="{FF2B5EF4-FFF2-40B4-BE49-F238E27FC236}">
-                <a16:creationId xmlns:a16="http://schemas.microsoft.com/office/drawing/2014/main" id="{1EE685C4-EF04-47AE-8B7F-819D8A0FEF30}"/>
+                <a16:creationId xmlns:a16="http://schemas.microsoft.com/office/drawing/2014/main" id="{D4E36F28-AE62-407C-A385-A7E2CA546E51}"/>
               </a:ext>
             </a:extLst>
           </p:cNvPr>
@@ -11204,7 +11199,7 @@
           <p:cNvPr id="8" name="">
             <a:extLst xmlns:a="http://schemas.openxmlformats.org/drawingml/2006/main">
               <a:ext uri="{FF2B5EF4-FFF2-40B4-BE49-F238E27FC236}">
-                <a16:creationId xmlns:a16="http://schemas.microsoft.com/office/drawing/2014/main" id="{36BB95DB-7F77-4905-9EEB-27AFEAAFA757}"/>
+                <a16:creationId xmlns:a16="http://schemas.microsoft.com/office/drawing/2014/main" id="{FEBFE631-FACB-4CB7-9A11-D2DE53CB5BEA}"/>
               </a:ext>
             </a:extLst>
           </p:cNvPr>
@@ -11322,7 +11317,7 @@
           <p:cNvPr id="9" name="">
             <a:extLst xmlns:a="http://schemas.openxmlformats.org/drawingml/2006/main">
               <a:ext uri="{FF2B5EF4-FFF2-40B4-BE49-F238E27FC236}">
-                <a16:creationId xmlns:a16="http://schemas.microsoft.com/office/drawing/2014/main" id="{84CB4349-138B-41E5-8162-28D5A21FD0C9}"/>
+                <a16:creationId xmlns:a16="http://schemas.microsoft.com/office/drawing/2014/main" id="{E61A13F5-9737-486D-ABA2-FFCBDFC230BB}"/>
               </a:ext>
             </a:extLst>
           </p:cNvPr>
@@ -11372,7 +11367,7 @@
           <p:cNvPr id="10" name="">
             <a:extLst xmlns:a="http://schemas.openxmlformats.org/drawingml/2006/main">
               <a:ext uri="{FF2B5EF4-FFF2-40B4-BE49-F238E27FC236}">
-                <a16:creationId xmlns:a16="http://schemas.microsoft.com/office/drawing/2014/main" id="{677B4962-01E7-40DE-BC9E-26DE57CA5BFE}"/>
+                <a16:creationId xmlns:a16="http://schemas.microsoft.com/office/drawing/2014/main" id="{C6D59D63-2C69-4CF0-A329-536F853DA7D2}"/>
               </a:ext>
             </a:extLst>
           </p:cNvPr>
@@ -11439,7 +11434,7 @@
           <p:cNvPr id="11" name="">
             <a:extLst xmlns:a="http://schemas.openxmlformats.org/drawingml/2006/main">
               <a:ext uri="{FF2B5EF4-FFF2-40B4-BE49-F238E27FC236}">
-                <a16:creationId xmlns:a16="http://schemas.microsoft.com/office/drawing/2014/main" id="{088FFDD5-246B-4F46-85BB-40156370F7F0}"/>
+                <a16:creationId xmlns:a16="http://schemas.microsoft.com/office/drawing/2014/main" id="{715C31A2-7412-4AE8-BFC1-4B3016D8328F}"/>
               </a:ext>
             </a:extLst>
           </p:cNvPr>
@@ -11489,7 +11484,7 @@
           <p:cNvPr id="12" name="">
             <a:extLst xmlns:a="http://schemas.openxmlformats.org/drawingml/2006/main">
               <a:ext uri="{FF2B5EF4-FFF2-40B4-BE49-F238E27FC236}">
-                <a16:creationId xmlns:a16="http://schemas.microsoft.com/office/drawing/2014/main" id="{86784248-3DC1-4E02-9C94-FAB8786D13E1}"/>
+                <a16:creationId xmlns:a16="http://schemas.microsoft.com/office/drawing/2014/main" id="{E9DB75C8-237D-4074-B109-1F34B3A1A30C}"/>
               </a:ext>
             </a:extLst>
           </p:cNvPr>
@@ -11543,7 +11538,7 @@
           <p:cNvPr id="13" name="">
             <a:extLst xmlns:a="http://schemas.openxmlformats.org/drawingml/2006/main">
               <a:ext uri="{FF2B5EF4-FFF2-40B4-BE49-F238E27FC236}">
-                <a16:creationId xmlns:a16="http://schemas.microsoft.com/office/drawing/2014/main" id="{CF29E385-FD28-4F32-B3CC-09D359A607DD}"/>
+                <a16:creationId xmlns:a16="http://schemas.microsoft.com/office/drawing/2014/main" id="{85566051-669A-4567-B320-29BA37D1968F}"/>
               </a:ext>
             </a:extLst>
           </p:cNvPr>
@@ -11555,7 +11550,7 @@
         <p:spPr>
           <a:xfrm xmlns:a="http://schemas.openxmlformats.org/drawingml/2006/main">
             <a:off x="2724150" y="5314950"/>
-            <a:ext cx="4629150" cy="342900"/>
+            <a:ext cx="5715000" cy="342900"/>
           </a:xfrm>
           <a:prstGeom xmlns:a="http://schemas.openxmlformats.org/drawingml/2006/main" prst="rect">
             <a:avLst/>
@@ -11583,7 +11578,7 @@
                   <a:srgbClr val="FFFFFF"/>
                 </a:solidFill>
               </a:rPr>
-              <a:t>Next: capture verified results and footage after Gate B.</a:t>
+              <a:t>Next: Gate B, 6-hour freeze, browser capture, two human reviews.</a:t>
             </a:r>
           </a:p>
         </p:txBody>
@@ -11591,7 +11586,7 @@
     </p:spTree>
     <p:extLst>
       <p:ext uri="{BB962C8B-B14F-4D97-AF65-F5344CB8AC3E}">
-        <p14:creationId xmlns:p14="http://schemas.microsoft.com/office/powerpoint/2010/main" val="1524498413"/>
+        <p14:creationId xmlns:p14="http://schemas.microsoft.com/office/powerpoint/2010/main" val="805489014"/>
       </p:ext>
     </p:extLst>
   </p:cSld>

</xml_diff>